<commit_message>
Update presentation: add SAME-padding bonus slide, fix stale VALID-build numbers, two-column results table
</commit_message>
<xml_diff>
--- a/docs/SSCS2026_presentation.pptx
+++ b/docs/SSCS2026_presentation.pptx
@@ -17,9 +17,10 @@
     <p:sldId id="265" r:id="rId11"/>
     <p:sldId id="266" r:id="rId12"/>
     <p:sldId id="267" r:id="rId13"/>
+    <p:sldId id="268" r:id="rId14"/>
   </p:sldIdLst>
   <p:notesMasterIdLst>
-    <p:notesMasterId r:id="rId14"/>
+    <p:notesMasterId r:id="rId15"/>
   </p:notesMasterIdLst>
   <p:sldSz cx="12192000" cy="6858000"/>
   <p:notesSz cx="6858000" cy="12192000"/>
@@ -805,7 +806,7 @@
           <a:p>
             <a:r>
               <a:rPr lang="en-US" dirty="0"/>
-              <a:t>Be upfront about the leakage. A 28nm part would report far lower total power for reasons unrelated to design quality.</a:t>
+              <a:t>Emphasize the word 'proven' -- this is a monitored testbench result, not an inference from a smaller violation count.</a:t>
             </a:r>
             <a:endParaRPr lang="en-US" dirty="0"/>
           </a:p>
@@ -893,7 +894,7 @@
           <a:p>
             <a:r>
               <a:rPr lang="en-US" dirty="0"/>
-              <a:t>This is the required table format from the competition announcement, filled in with measured values.</a:t>
+              <a:t>Be upfront about the leakage. A 28nm part would report far lower total power for reasons unrelated to design quality.</a:t>
             </a:r>
             <a:endParaRPr lang="en-US" dirty="0"/>
           </a:p>
@@ -981,7 +982,7 @@
           <a:p>
             <a:r>
               <a:rPr lang="en-US" dirty="0"/>
-              <a:t>Close by naming what is left: the two bonus items. The bitstream exists, only board access is pending.</a:t>
+              <a:t>This is the required table format from the competition announcement, filled in with measured values.</a:t>
             </a:r>
             <a:endParaRPr lang="en-US" dirty="0"/>
           </a:p>
@@ -1005,6 +1006,94 @@
             <a:fld id="{F7021451-1387-4CA6-816F-3879F97B5CBC}" type="slidenum">
               <a:rPr lang="en-US"/>
               <a:t>12</a:t>
+            </a:fld>
+            <a:endParaRPr lang="en-US"/>
+          </a:p>
+        </p:txBody>
+      </p:sp>
+    </p:spTree>
+    <p:extLst>
+      <p:ext uri="{BB962C8B-B14F-4D97-AF65-F5344CB8AC3E}">
+        <p14:creationId xmlns:p14="http://schemas.microsoft.com/office/powerpoint/2010/main" val="1024086991"/>
+      </p:ext>
+    </p:extLst>
+  </p:cSld>
+  <p:clrMapOvr>
+    <a:masterClrMapping/>
+  </p:clrMapOvr>
+</p:notes>
+</file>
+
+<file path=ppt/notesSlides/notesSlide13.xml><?xml version="1.0" encoding="utf-8"?>
+<p:notes xmlns:a="http://schemas.openxmlformats.org/drawingml/2006/main" xmlns:r="http://schemas.openxmlformats.org/officeDocument/2006/relationships" xmlns:p="http://schemas.openxmlformats.org/presentationml/2006/main">
+  <p:cSld>
+    <p:spTree>
+      <p:nvGrpSpPr>
+        <p:cNvPr id="1" name=""/>
+        <p:cNvGrpSpPr/>
+        <p:nvPr/>
+      </p:nvGrpSpPr>
+      <p:grpSpPr>
+        <a:xfrm>
+          <a:off x="0" y="0"/>
+          <a:ext cx="0" cy="0"/>
+          <a:chOff x="0" y="0"/>
+          <a:chExt cx="0" cy="0"/>
+        </a:xfrm>
+      </p:grpSpPr>
+      <p:sp>
+        <p:nvSpPr>
+          <p:cNvPr id="2" name="Slide Image Placeholder 1"/>
+          <p:cNvSpPr>
+            <a:spLocks noGrp="1" noRot="1" noChangeAspect="1"/>
+          </p:cNvSpPr>
+          <p:nvPr>
+            <p:ph type="sldImg"/>
+          </p:nvPr>
+        </p:nvSpPr>
+        <p:spPr/>
+      </p:sp>
+      <p:sp>
+        <p:nvSpPr>
+          <p:cNvPr id="3" name="Notes Placeholder 2"/>
+          <p:cNvSpPr>
+            <a:spLocks noGrp="1"/>
+          </p:cNvSpPr>
+          <p:nvPr>
+            <p:ph type="body" idx="1"/>
+          </p:nvPr>
+        </p:nvSpPr>
+        <p:spPr/>
+        <p:txBody>
+          <a:bodyPr/>
+          <a:lstStyle/>
+          <a:p>
+            <a:r>
+              <a:rPr lang="en-US" dirty="0"/>
+              <a:t>Close by naming what is left: the two bonus items. The bitstream exists, only board access is pending.</a:t>
+            </a:r>
+            <a:endParaRPr lang="en-US" dirty="0"/>
+          </a:p>
+        </p:txBody>
+      </p:sp>
+      <p:sp>
+        <p:nvSpPr>
+          <p:cNvPr id="4" name="Slide Number Placeholder 3"/>
+          <p:cNvSpPr>
+            <a:spLocks noGrp="1"/>
+          </p:cNvSpPr>
+          <p:nvPr>
+            <p:ph type="sldNum" sz="quarter" idx="10"/>
+          </p:nvPr>
+        </p:nvSpPr>
+        <p:spPr/>
+        <p:txBody>
+          <a:bodyPr/>
+          <a:lstStyle/>
+          <a:p>
+            <a:fld id="{F7021451-1387-4CA6-816F-3879F97B5CBC}" type="slidenum">
+              <a:rPr lang="en-US"/>
+              <a:t>13</a:t>
             </a:fld>
             <a:endParaRPr lang="en-US"/>
           </a:p>
@@ -2346,7 +2435,7 @@
                 <a:ea typeface="Calibri" pitchFamily="34" charset="-122"/>
                 <a:cs typeface="Calibri" pitchFamily="34" charset="-120"/>
               </a:rPr>
-              <a:t>MEMORY STRATEGY</a:t>
+              <a:t>ZERO-GAP STREAMING</a:t>
             </a:r>
             <a:endParaRPr lang="en-US" sz="1100" dirty="0"/>
           </a:p>
@@ -2385,7 +2474,7 @@
                 <a:ea typeface="Cambria" pitchFamily="34" charset="-122"/>
                 <a:cs typeface="Cambria" pitchFamily="34" charset="-120"/>
               </a:rPr>
-              <a:t>Zero block RAM, by construction</a:t>
+              <a:t>Earning the one-output-per-cycle bonus</a:t>
             </a:r>
             <a:endParaRPr lang="en-US" sz="3200" dirty="0"/>
           </a:p>
@@ -2393,18 +2482,162 @@
       </p:sp>
       <p:sp>
         <p:nvSpPr>
-          <p:cNvPr id="4" name="Shape 2"/>
-          <p:cNvSpPr/>
-          <p:nvPr/>
-        </p:nvSpPr>
-        <p:spPr>
-          <a:xfrm>
-            <a:off x="548640" y="1645920"/>
-            <a:ext cx="5394960" cy="2103120"/>
+          <p:cNvPr id="4" name="Text 2"/>
+          <p:cNvSpPr/>
+          <p:nvPr/>
+        </p:nvSpPr>
+        <p:spPr>
+          <a:xfrm>
+            <a:off x="548640" y="1444752"/>
+            <a:ext cx="11064240" cy="365760"/>
+          </a:xfrm>
+          <a:prstGeom prst="rect">
+            <a:avLst/>
+          </a:prstGeom>
+          <a:noFill/>
+          <a:ln/>
+        </p:spPr>
+        <p:txBody>
+          <a:bodyPr wrap="square" lIns="0" tIns="0" rIns="0" bIns="0" rtlCol="0" anchor="ctr"/>
+          <a:lstStyle/>
+          <a:p>
+            <a:pPr indent="0" marL="0">
+              <a:buNone/>
+            </a:pPr>
+            <a:r>
+              <a:rPr lang="en-US" sz="1350" dirty="0">
+                <a:solidFill>
+                  <a:srgbClr val="5C6B7A"/>
+                </a:solidFill>
+                <a:latin typeface="Calibri" pitchFamily="34" charset="0"/>
+                <a:ea typeface="Calibri" pitchFamily="34" charset="-122"/>
+                <a:cs typeface="Calibri" pitchFamily="34" charset="-120"/>
+              </a:rPr>
+              <a:t>The organizer's bar: out_valid must never drop for 2+ cycles during processing — not even at row boundaries.</a:t>
+            </a:r>
+            <a:endParaRPr lang="en-US" sz="1350" dirty="0"/>
+          </a:p>
+        </p:txBody>
+      </p:sp>
+      <p:sp>
+        <p:nvSpPr>
+          <p:cNvPr id="5" name="Shape 3"/>
+          <p:cNvSpPr/>
+          <p:nvPr/>
+        </p:nvSpPr>
+        <p:spPr>
+          <a:xfrm>
+            <a:off x="548640" y="1920240"/>
+            <a:ext cx="5349240" cy="1965960"/>
           </a:xfrm>
           <a:prstGeom prst="roundRect">
             <a:avLst>
-              <a:gd name="adj" fmla="val 2609"/>
+              <a:gd name="adj" fmla="val 2791"/>
+            </a:avLst>
+          </a:prstGeom>
+          <a:solidFill>
+            <a:srgbClr val="FDF0EE"/>
+          </a:solidFill>
+          <a:ln w="9525">
+            <a:solidFill>
+              <a:srgbClr val="DCE5EC"/>
+            </a:solidFill>
+            <a:prstDash val="solid"/>
+          </a:ln>
+        </p:spPr>
+      </p:sp>
+      <p:sp>
+        <p:nvSpPr>
+          <p:cNvPr id="6" name="Text 4"/>
+          <p:cNvSpPr/>
+          <p:nvPr/>
+        </p:nvSpPr>
+        <p:spPr>
+          <a:xfrm>
+            <a:off x="804672" y="2103120"/>
+            <a:ext cx="4846320" cy="329184"/>
+          </a:xfrm>
+          <a:prstGeom prst="rect">
+            <a:avLst/>
+          </a:prstGeom>
+          <a:noFill/>
+          <a:ln/>
+        </p:spPr>
+        <p:txBody>
+          <a:bodyPr wrap="square" lIns="0" tIns="0" rIns="0" bIns="0" rtlCol="0" anchor="ctr"/>
+          <a:lstStyle/>
+          <a:p>
+            <a:pPr indent="0" marL="0">
+              <a:buNone/>
+            </a:pPr>
+            <a:r>
+              <a:rPr lang="en-US" sz="1450" b="1" dirty="0">
+                <a:solidFill>
+                  <a:srgbClr val="C0392B"/>
+                </a:solidFill>
+                <a:latin typeface="Calibri" pitchFamily="34" charset="0"/>
+                <a:ea typeface="Calibri" pitchFamily="34" charset="-122"/>
+                <a:cs typeface="Calibri" pitchFamily="34" charset="-120"/>
+              </a:rPr>
+              <a:t>First attempt: padding pixels</a:t>
+            </a:r>
+            <a:endParaRPr lang="en-US" sz="1450" dirty="0"/>
+          </a:p>
+        </p:txBody>
+      </p:sp>
+      <p:sp>
+        <p:nvSpPr>
+          <p:cNvPr id="7" name="Text 5"/>
+          <p:cNvSpPr/>
+          <p:nvPr/>
+        </p:nvSpPr>
+        <p:spPr>
+          <a:xfrm>
+            <a:off x="804672" y="2468880"/>
+            <a:ext cx="4892040" cy="1325880"/>
+          </a:xfrm>
+          <a:prstGeom prst="rect">
+            <a:avLst/>
+          </a:prstGeom>
+          <a:noFill/>
+          <a:ln/>
+        </p:spPr>
+        <p:txBody>
+          <a:bodyPr wrap="square" lIns="0" tIns="0" rIns="0" bIns="0" rtlCol="0" anchor="ctr"/>
+          <a:lstStyle/>
+          <a:p>
+            <a:pPr indent="0" marL="0">
+              <a:buNone/>
+            </a:pPr>
+            <a:r>
+              <a:rPr lang="en-US" sz="1200" dirty="0">
+                <a:solidFill>
+                  <a:srgbClr val="16222E"/>
+                </a:solidFill>
+                <a:latin typeface="Calibri" pitchFamily="34" charset="0"/>
+                <a:ea typeface="Calibri" pitchFamily="34" charset="-122"/>
+                <a:cs typeface="Calibri" pitchFamily="34" charset="-120"/>
+              </a:rPr>
+              <a:t>Injected literal zero pixels between rows to zero-pad the math. Correct values — but each injected pixel cost one real cycle: 2-cycle stall at every row boundary, 31 violations measured directly.</a:t>
+            </a:r>
+            <a:endParaRPr lang="en-US" sz="1200" dirty="0"/>
+          </a:p>
+        </p:txBody>
+      </p:sp>
+      <p:sp>
+        <p:nvSpPr>
+          <p:cNvPr id="8" name="Shape 6"/>
+          <p:cNvSpPr/>
+          <p:nvPr/>
+        </p:nvSpPr>
+        <p:spPr>
+          <a:xfrm>
+            <a:off x="6172200" y="1920240"/>
+            <a:ext cx="5440680" cy="1965960"/>
+          </a:xfrm>
+          <a:prstGeom prst="roundRect">
+            <a:avLst>
+              <a:gd name="adj" fmla="val 2791"/>
             </a:avLst>
           </a:prstGeom>
           <a:solidFill>
@@ -2420,14 +2653,14 @@
       </p:sp>
       <p:sp>
         <p:nvSpPr>
-          <p:cNvPr id="5" name="Text 3"/>
-          <p:cNvSpPr/>
-          <p:nvPr/>
-        </p:nvSpPr>
-        <p:spPr>
-          <a:xfrm>
-            <a:off x="822960" y="1847088"/>
-            <a:ext cx="4754880" cy="329184"/>
+          <p:cNvPr id="9" name="Text 7"/>
+          <p:cNvSpPr/>
+          <p:nvPr/>
+        </p:nvSpPr>
+        <p:spPr>
+          <a:xfrm>
+            <a:off x="6428232" y="2103120"/>
+            <a:ext cx="4937760" cy="329184"/>
           </a:xfrm>
           <a:prstGeom prst="rect">
             <a:avLst/>
@@ -2443,7 +2676,7 @@
               <a:buNone/>
             </a:pPr>
             <a:r>
-              <a:rPr lang="en-US" sz="1500" b="1" dirty="0">
+              <a:rPr lang="en-US" sz="1450" b="1" dirty="0">
                 <a:solidFill>
                   <a:srgbClr val="065A82"/>
                 </a:solidFill>
@@ -2451,22 +2684,22 @@
                 <a:ea typeface="Calibri" pitchFamily="34" charset="-122"/>
                 <a:cs typeface="Calibri" pitchFamily="34" charset="-120"/>
               </a:rPr>
-              <a:t>The line buffers</a:t>
-            </a:r>
-            <a:endParaRPr lang="en-US" sz="1500" dirty="0"/>
-          </a:p>
-        </p:txBody>
-      </p:sp>
-      <p:sp>
-        <p:nvSpPr>
-          <p:cNvPr id="6" name="Text 4"/>
-          <p:cNvSpPr/>
-          <p:nvPr/>
-        </p:nvSpPr>
-        <p:spPr>
-          <a:xfrm>
-            <a:off x="822960" y="2249424"/>
-            <a:ext cx="4846320" cy="1280160"/>
+              <a:t>Fix: mask, don't inject</a:t>
+            </a:r>
+            <a:endParaRPr lang="en-US" sz="1450" dirty="0"/>
+          </a:p>
+        </p:txBody>
+      </p:sp>
+      <p:sp>
+        <p:nvSpPr>
+          <p:cNvPr id="10" name="Text 8"/>
+          <p:cNvSpPr/>
+          <p:nvPr/>
+        </p:nvSpPr>
+        <p:spPr>
+          <a:xfrm>
+            <a:off x="6428232" y="2468880"/>
+            <a:ext cx="4983480" cy="1325880"/>
           </a:xfrm>
           <a:prstGeom prst="rect">
             <a:avLst/>
@@ -2482,112 +2715,7 @@
               <a:buNone/>
             </a:pPr>
             <a:r>
-              <a:rPr lang="en-US" sz="1300" dirty="0">
-                <a:solidFill>
-                  <a:srgbClr val="5C6B7A"/>
-                </a:solidFill>
-                <a:latin typeface="Calibri" pitchFamily="34" charset="0"/>
-                <a:ea typeface="Calibri" pitchFamily="34" charset="-122"/>
-                <a:cs typeface="Calibri" pitchFamily="34" charset="-120"/>
-              </a:rPr>
-              <a:t>Two 256-bit flat shift registers, which XST infers as sixteen 30-bit SRL primitives occupying 17 LUTs in total — confirmed in the map report.</a:t>
-            </a:r>
-            <a:endParaRPr lang="en-US" sz="1300" dirty="0"/>
-          </a:p>
-        </p:txBody>
-      </p:sp>
-      <p:sp>
-        <p:nvSpPr>
-          <p:cNvPr id="7" name="Shape 5"/>
-          <p:cNvSpPr/>
-          <p:nvPr/>
-        </p:nvSpPr>
-        <p:spPr>
-          <a:xfrm>
-            <a:off x="6217920" y="1645920"/>
-            <a:ext cx="5394960" cy="2103120"/>
-          </a:xfrm>
-          <a:prstGeom prst="roundRect">
-            <a:avLst>
-              <a:gd name="adj" fmla="val 2609"/>
-            </a:avLst>
-          </a:prstGeom>
-          <a:solidFill>
-            <a:srgbClr val="FDF0EE"/>
-          </a:solidFill>
-          <a:ln w="9525">
-            <a:solidFill>
-              <a:srgbClr val="DCE5EC"/>
-            </a:solidFill>
-            <a:prstDash val="solid"/>
-          </a:ln>
-        </p:spPr>
-      </p:sp>
-      <p:sp>
-        <p:nvSpPr>
-          <p:cNvPr id="8" name="Text 6"/>
-          <p:cNvSpPr/>
-          <p:nvPr/>
-        </p:nvSpPr>
-        <p:spPr>
-          <a:xfrm>
-            <a:off x="6492240" y="1847088"/>
-            <a:ext cx="4754880" cy="329184"/>
-          </a:xfrm>
-          <a:prstGeom prst="rect">
-            <a:avLst/>
-          </a:prstGeom>
-          <a:noFill/>
-          <a:ln/>
-        </p:spPr>
-        <p:txBody>
-          <a:bodyPr wrap="square" lIns="0" tIns="0" rIns="0" bIns="0" rtlCol="0" anchor="ctr"/>
-          <a:lstStyle/>
-          <a:p>
-            <a:pPr indent="0" marL="0">
-              <a:buNone/>
-            </a:pPr>
-            <a:r>
-              <a:rPr lang="en-US" sz="1500" b="1" dirty="0">
-                <a:solidFill>
-                  <a:srgbClr val="C0392B"/>
-                </a:solidFill>
-                <a:latin typeface="Calibri" pitchFamily="34" charset="0"/>
-                <a:ea typeface="Calibri" pitchFamily="34" charset="-122"/>
-                <a:cs typeface="Calibri" pitchFamily="34" charset="-120"/>
-              </a:rPr>
-              <a:t>Why it matters</a:t>
-            </a:r>
-            <a:endParaRPr lang="en-US" sz="1500" dirty="0"/>
-          </a:p>
-        </p:txBody>
-      </p:sp>
-      <p:sp>
-        <p:nvSpPr>
-          <p:cNvPr id="9" name="Text 7"/>
-          <p:cNvSpPr/>
-          <p:nvPr/>
-        </p:nvSpPr>
-        <p:spPr>
-          <a:xfrm>
-            <a:off x="6492240" y="2249424"/>
-            <a:ext cx="4846320" cy="1280160"/>
-          </a:xfrm>
-          <a:prstGeom prst="rect">
-            <a:avLst/>
-          </a:prstGeom>
-          <a:noFill/>
-          <a:ln/>
-        </p:spPr>
-        <p:txBody>
-          <a:bodyPr wrap="square" lIns="0" tIns="0" rIns="0" bIns="0" rtlCol="0" anchor="ctr"/>
-          <a:lstStyle/>
-          <a:p>
-            <a:pPr indent="0" marL="0">
-              <a:buNone/>
-            </a:pPr>
-            <a:r>
-              <a:rPr lang="en-US" sz="1300" dirty="0">
+              <a:rPr lang="en-US" sz="1200" dirty="0">
                 <a:solidFill>
                   <a:srgbClr val="16222E"/>
                 </a:solidFill>
@@ -2595,81 +2723,26 @@
                 <a:ea typeface="Calibri" pitchFamily="34" charset="-122"/>
                 <a:cs typeface="Calibri" pitchFamily="34" charset="-120"/>
               </a:rPr>
-              <a:t>One BRAM would have cost at least 100 penalty units — more than a third of the entire LUT budget of the submitted design — to store 512 bits.</a:t>
-            </a:r>
-            <a:endParaRPr lang="en-US" sz="1300" dirty="0"/>
-          </a:p>
-        </p:txBody>
-      </p:sp>
-      <p:sp>
-        <p:nvSpPr>
-          <p:cNvPr id="10" name="Text 8"/>
-          <p:cNvSpPr/>
-          <p:nvPr/>
-        </p:nvSpPr>
-        <p:spPr>
-          <a:xfrm>
-            <a:off x="548640" y="3968496"/>
-            <a:ext cx="5486400" cy="365760"/>
-          </a:xfrm>
-          <a:prstGeom prst="rect">
-            <a:avLst/>
-          </a:prstGeom>
-          <a:noFill/>
-          <a:ln/>
-        </p:spPr>
-        <p:txBody>
-          <a:bodyPr wrap="square" lIns="0" tIns="0" rIns="0" bIns="0" rtlCol="0" anchor="ctr"/>
-          <a:lstStyle/>
-          <a:p>
-            <a:pPr indent="0" marL="0">
-              <a:buNone/>
-            </a:pPr>
-            <a:r>
-              <a:rPr lang="en-US" sz="1600" b="1" dirty="0">
-                <a:solidFill>
-                  <a:srgbClr val="16222E"/>
-                </a:solidFill>
-                <a:latin typeface="Calibri" pitchFamily="34" charset="0"/>
-                <a:ea typeface="Calibri" pitchFamily="34" charset="-122"/>
-                <a:cs typeface="Calibri" pitchFamily="34" charset="-120"/>
-              </a:rPr>
-              <a:t>Power breakdown</a:t>
-            </a:r>
-            <a:endParaRPr lang="en-US" sz="1600" dirty="0"/>
-          </a:p>
-        </p:txBody>
-      </p:sp>
-      <p:graphicFrame>
-        <p:nvGraphicFramePr>
-          <p:cNvPr id="11" name="Chart 0" descr=""/>
-          <p:cNvGraphicFramePr/>
-          <p:nvPr/>
-        </p:nvGraphicFramePr>
-        <p:xfrm>
-          <a:off x="457200" y="4206240"/>
-          <a:ext cx="4023360" cy="2286000"/>
-        </p:xfrm>
-        <a:graphic xmlns:a="http://schemas.openxmlformats.org/drawingml/2006/main">
-          <a:graphicData uri="http://schemas.openxmlformats.org/drawingml/2006/chart">
-            <c:chart xmlns:c="http://schemas.openxmlformats.org/drawingml/2006/chart" r:id="rId1"/>
-          </a:graphicData>
-        </a:graphic>
-      </p:graphicFrame>
-      <p:sp>
-        <p:nvSpPr>
-          <p:cNvPr id="12" name="Shape 9"/>
-          <p:cNvSpPr/>
-          <p:nvPr/>
-        </p:nvSpPr>
-        <p:spPr>
-          <a:xfrm>
-            <a:off x="4846320" y="4370832"/>
-            <a:ext cx="6766560" cy="1920240"/>
+              <a:t>Top padding comes free from line-buffer reset timing. Left padding is applied by masking the window's oldest columns to zero — no pixel ever costs a cycle. Every real pixel produces one output.</a:t>
+            </a:r>
+            <a:endParaRPr lang="en-US" sz="1200" dirty="0"/>
+          </a:p>
+        </p:txBody>
+      </p:sp>
+      <p:sp>
+        <p:nvSpPr>
+          <p:cNvPr id="11" name="Shape 9"/>
+          <p:cNvSpPr/>
+          <p:nvPr/>
+        </p:nvSpPr>
+        <p:spPr>
+          <a:xfrm>
+            <a:off x="548640" y="4069080"/>
+            <a:ext cx="11064240" cy="1737360"/>
           </a:xfrm>
           <a:prstGeom prst="roundRect">
             <a:avLst>
-              <a:gd name="adj" fmla="val 2857"/>
+              <a:gd name="adj" fmla="val 3158"/>
             </a:avLst>
           </a:prstGeom>
           <a:solidFill>
@@ -2685,14 +2758,14 @@
       </p:sp>
       <p:sp>
         <p:nvSpPr>
-          <p:cNvPr id="13" name="Text 10"/>
-          <p:cNvSpPr/>
-          <p:nvPr/>
-        </p:nvSpPr>
-        <p:spPr>
-          <a:xfrm>
-            <a:off x="5120640" y="4572000"/>
-            <a:ext cx="6309360" cy="822960"/>
+          <p:cNvPr id="12" name="Text 10"/>
+          <p:cNvSpPr/>
+          <p:nvPr/>
+        </p:nvSpPr>
+        <p:spPr>
+          <a:xfrm>
+            <a:off x="822960" y="4233672"/>
+            <a:ext cx="4572000" cy="310896"/>
           </a:xfrm>
           <a:prstGeom prst="rect">
             <a:avLst/>
@@ -2708,7 +2781,46 @@
               <a:buNone/>
             </a:pPr>
             <a:r>
-              <a:rPr lang="en-US" sz="1300" dirty="0">
+              <a:rPr lang="en-US" sz="1400" b="1" dirty="0">
+                <a:solidFill>
+                  <a:srgbClr val="1C7293"/>
+                </a:solidFill>
+                <a:latin typeface="Calibri" pitchFamily="34" charset="0"/>
+                <a:ea typeface="Calibri" pitchFamily="34" charset="-122"/>
+                <a:cs typeface="Calibri" pitchFamily="34" charset="-120"/>
+              </a:rPr>
+              <a:t>Proven, not asserted</a:t>
+            </a:r>
+            <a:endParaRPr lang="en-US" sz="1400" dirty="0"/>
+          </a:p>
+        </p:txBody>
+      </p:sp>
+      <p:sp>
+        <p:nvSpPr>
+          <p:cNvPr id="13" name="Text 11"/>
+          <p:cNvSpPr/>
+          <p:nvPr/>
+        </p:nvSpPr>
+        <p:spPr>
+          <a:xfrm>
+            <a:off x="822960" y="4572000"/>
+            <a:ext cx="10515600" cy="548640"/>
+          </a:xfrm>
+          <a:prstGeom prst="rect">
+            <a:avLst/>
+          </a:prstGeom>
+          <a:noFill/>
+          <a:ln/>
+        </p:spPr>
+        <p:txBody>
+          <a:bodyPr wrap="square" lIns="0" tIns="0" rIns="0" bIns="0" rtlCol="0" anchor="ctr"/>
+          <a:lstStyle/>
+          <a:p>
+            <a:pPr indent="0" marL="0">
+              <a:buNone/>
+            </a:pPr>
+            <a:r>
+              <a:rPr lang="en-US" sz="1250" dirty="0">
                 <a:solidFill>
                   <a:srgbClr val="16222E"/>
                 </a:solidFill>
@@ -2716,22 +2828,22 @@
                 <a:ea typeface="Calibri" pitchFamily="34" charset="-122"/>
                 <a:cs typeface="Calibri" pitchFamily="34" charset="-120"/>
               </a:rPr>
-              <a:t>Only 21 mW of the 476 mW total is dynamic. The remaining 455 mW is static leakage inherent to the 65 nm Virtex-5 process and independent of the design — it is the same figure our earlier work measured on this board.</a:t>
-            </a:r>
-            <a:endParaRPr lang="en-US" sz="1300" dirty="0"/>
-          </a:p>
-        </p:txBody>
-      </p:sp>
-      <p:sp>
-        <p:nvSpPr>
-          <p:cNvPr id="14" name="Text 11"/>
-          <p:cNvSpPr/>
-          <p:nvPr/>
-        </p:nvSpPr>
-        <p:spPr>
-          <a:xfrm>
-            <a:off x="5120640" y="5413248"/>
-            <a:ext cx="6309360" cy="731520"/>
+              <a:t>A dedicated testbench feeds the core 1,024 real pixels continuously — no padding pixels of any kind — and a cycle-by-cycle monitor tracks every gap in out_valid.</a:t>
+            </a:r>
+            <a:endParaRPr lang="en-US" sz="1250" dirty="0"/>
+          </a:p>
+        </p:txBody>
+      </p:sp>
+      <p:sp>
+        <p:nvSpPr>
+          <p:cNvPr id="14" name="Text 12"/>
+          <p:cNvSpPr/>
+          <p:nvPr/>
+        </p:nvSpPr>
+        <p:spPr>
+          <a:xfrm>
+            <a:off x="822960" y="5102352"/>
+            <a:ext cx="10515600" cy="365760"/>
           </a:xfrm>
           <a:prstGeom prst="rect">
             <a:avLst/>
@@ -2747,7 +2859,46 @@
               <a:buNone/>
             </a:pPr>
             <a:r>
-              <a:rPr lang="en-US" sz="1250" i="1" dirty="0">
+              <a:rPr lang="en-US" sz="1400" b="1" dirty="0">
+                <a:solidFill>
+                  <a:srgbClr val="065A82"/>
+                </a:solidFill>
+                <a:latin typeface="Courier New" pitchFamily="34" charset="0"/>
+                <a:ea typeface="Courier New" pitchFamily="34" charset="-122"/>
+                <a:cs typeface="Courier New" pitchFamily="34" charset="-120"/>
+              </a:rPr>
+              <a:t>Result:  1024 / 1024 bit-exact   ·   max gap = 0 cycles   ·   violations ≥ 2 cycles = 0</a:t>
+            </a:r>
+            <a:endParaRPr lang="en-US" sz="1400" dirty="0"/>
+          </a:p>
+        </p:txBody>
+      </p:sp>
+      <p:sp>
+        <p:nvSpPr>
+          <p:cNvPr id="15" name="Text 13"/>
+          <p:cNvSpPr/>
+          <p:nvPr/>
+        </p:nvSpPr>
+        <p:spPr>
+          <a:xfrm>
+            <a:off x="548640" y="5943600"/>
+            <a:ext cx="11064240" cy="365760"/>
+          </a:xfrm>
+          <a:prstGeom prst="rect">
+            <a:avLst/>
+          </a:prstGeom>
+          <a:noFill/>
+          <a:ln/>
+        </p:spPr>
+        <p:txBody>
+          <a:bodyPr wrap="square" lIns="0" tIns="0" rIns="0" bIns="0" rtlCol="0" anchor="ctr"/>
+          <a:lstStyle/>
+          <a:p>
+            <a:pPr indent="0" marL="0">
+              <a:buNone/>
+            </a:pPr>
+            <a:r>
+              <a:rPr lang="en-US" sz="1200" i="1" dirty="0">
                 <a:solidFill>
                   <a:srgbClr val="5C6B7A"/>
                 </a:solidFill>
@@ -2755,9 +2906,9 @@
                 <a:ea typeface="Calibri" pitchFamily="34" charset="-122"/>
                 <a:cs typeface="Calibri" pitchFamily="34" charset="-120"/>
               </a:rPr>
-              <a:t>Against dynamic power alone the FoM would be 5.52×10⁻², some 23× higher. We report total power as the official figure, as the conservative reading of the specification.</a:t>
-            </a:r>
-            <a:endParaRPr lang="en-US" sz="1250" dirty="0"/>
+              <a:t>Trade-off: +118 LUTs for the masking logic and output FIFO, throughput 0.8755 → 1.0. Net FoM change: −1.0% — reported honestly, not oversold.</a:t>
+            </a:r>
+            <a:endParaRPr lang="en-US" sz="1200" dirty="0"/>
           </a:p>
         </p:txBody>
       </p:sp>
@@ -2826,7 +2977,487 @@
                 <a:ea typeface="Calibri" pitchFamily="34" charset="-122"/>
                 <a:cs typeface="Calibri" pitchFamily="34" charset="-120"/>
               </a:rPr>
-              <a:t>POST-PLACE-AND-ROUTE</a:t>
+              <a:t>MEMORY STRATEGY</a:t>
+            </a:r>
+            <a:endParaRPr lang="en-US" sz="1100" dirty="0"/>
+          </a:p>
+        </p:txBody>
+      </p:sp>
+      <p:sp>
+        <p:nvSpPr>
+          <p:cNvPr id="3" name="Text 1"/>
+          <p:cNvSpPr/>
+          <p:nvPr/>
+        </p:nvSpPr>
+        <p:spPr>
+          <a:xfrm>
+            <a:off x="548640" y="621792"/>
+            <a:ext cx="11064240" cy="658368"/>
+          </a:xfrm>
+          <a:prstGeom prst="rect">
+            <a:avLst/>
+          </a:prstGeom>
+          <a:noFill/>
+          <a:ln/>
+        </p:spPr>
+        <p:txBody>
+          <a:bodyPr wrap="square" lIns="0" tIns="0" rIns="0" bIns="0" rtlCol="0" anchor="ctr"/>
+          <a:lstStyle/>
+          <a:p>
+            <a:pPr indent="0" marL="0">
+              <a:buNone/>
+            </a:pPr>
+            <a:r>
+              <a:rPr lang="en-US" sz="3200" b="1" dirty="0">
+                <a:solidFill>
+                  <a:srgbClr val="16222E"/>
+                </a:solidFill>
+                <a:latin typeface="Cambria" pitchFamily="34" charset="0"/>
+                <a:ea typeface="Cambria" pitchFamily="34" charset="-122"/>
+                <a:cs typeface="Cambria" pitchFamily="34" charset="-120"/>
+              </a:rPr>
+              <a:t>Zero block RAM, by construction</a:t>
+            </a:r>
+            <a:endParaRPr lang="en-US" sz="3200" dirty="0"/>
+          </a:p>
+        </p:txBody>
+      </p:sp>
+      <p:sp>
+        <p:nvSpPr>
+          <p:cNvPr id="4" name="Shape 2"/>
+          <p:cNvSpPr/>
+          <p:nvPr/>
+        </p:nvSpPr>
+        <p:spPr>
+          <a:xfrm>
+            <a:off x="548640" y="1645920"/>
+            <a:ext cx="5394960" cy="2103120"/>
+          </a:xfrm>
+          <a:prstGeom prst="roundRect">
+            <a:avLst>
+              <a:gd name="adj" fmla="val 2609"/>
+            </a:avLst>
+          </a:prstGeom>
+          <a:solidFill>
+            <a:srgbClr val="EEF3F7"/>
+          </a:solidFill>
+          <a:ln w="9525">
+            <a:solidFill>
+              <a:srgbClr val="DCE5EC"/>
+            </a:solidFill>
+            <a:prstDash val="solid"/>
+          </a:ln>
+        </p:spPr>
+      </p:sp>
+      <p:sp>
+        <p:nvSpPr>
+          <p:cNvPr id="5" name="Text 3"/>
+          <p:cNvSpPr/>
+          <p:nvPr/>
+        </p:nvSpPr>
+        <p:spPr>
+          <a:xfrm>
+            <a:off x="822960" y="1847088"/>
+            <a:ext cx="4754880" cy="329184"/>
+          </a:xfrm>
+          <a:prstGeom prst="rect">
+            <a:avLst/>
+          </a:prstGeom>
+          <a:noFill/>
+          <a:ln/>
+        </p:spPr>
+        <p:txBody>
+          <a:bodyPr wrap="square" lIns="0" tIns="0" rIns="0" bIns="0" rtlCol="0" anchor="ctr"/>
+          <a:lstStyle/>
+          <a:p>
+            <a:pPr indent="0" marL="0">
+              <a:buNone/>
+            </a:pPr>
+            <a:r>
+              <a:rPr lang="en-US" sz="1500" b="1" dirty="0">
+                <a:solidFill>
+                  <a:srgbClr val="065A82"/>
+                </a:solidFill>
+                <a:latin typeface="Calibri" pitchFamily="34" charset="0"/>
+                <a:ea typeface="Calibri" pitchFamily="34" charset="-122"/>
+                <a:cs typeface="Calibri" pitchFamily="34" charset="-120"/>
+              </a:rPr>
+              <a:t>The line buffers</a:t>
+            </a:r>
+            <a:endParaRPr lang="en-US" sz="1500" dirty="0"/>
+          </a:p>
+        </p:txBody>
+      </p:sp>
+      <p:sp>
+        <p:nvSpPr>
+          <p:cNvPr id="6" name="Text 4"/>
+          <p:cNvSpPr/>
+          <p:nvPr/>
+        </p:nvSpPr>
+        <p:spPr>
+          <a:xfrm>
+            <a:off x="822960" y="2249424"/>
+            <a:ext cx="4846320" cy="1280160"/>
+          </a:xfrm>
+          <a:prstGeom prst="rect">
+            <a:avLst/>
+          </a:prstGeom>
+          <a:noFill/>
+          <a:ln/>
+        </p:spPr>
+        <p:txBody>
+          <a:bodyPr wrap="square" lIns="0" tIns="0" rIns="0" bIns="0" rtlCol="0" anchor="ctr"/>
+          <a:lstStyle/>
+          <a:p>
+            <a:pPr indent="0" marL="0">
+              <a:buNone/>
+            </a:pPr>
+            <a:r>
+              <a:rPr lang="en-US" sz="1300" dirty="0">
+                <a:solidFill>
+                  <a:srgbClr val="5C6B7A"/>
+                </a:solidFill>
+                <a:latin typeface="Calibri" pitchFamily="34" charset="0"/>
+                <a:ea typeface="Calibri" pitchFamily="34" charset="-122"/>
+                <a:cs typeface="Calibri" pitchFamily="34" charset="-120"/>
+              </a:rPr>
+              <a:t>Two 256-bit flat shift registers, which XST infers as sixteen 30-bit SRL primitives occupying 17 LUTs in total — confirmed in the map report.</a:t>
+            </a:r>
+            <a:endParaRPr lang="en-US" sz="1300" dirty="0"/>
+          </a:p>
+        </p:txBody>
+      </p:sp>
+      <p:sp>
+        <p:nvSpPr>
+          <p:cNvPr id="7" name="Shape 5"/>
+          <p:cNvSpPr/>
+          <p:nvPr/>
+        </p:nvSpPr>
+        <p:spPr>
+          <a:xfrm>
+            <a:off x="6217920" y="1645920"/>
+            <a:ext cx="5394960" cy="2103120"/>
+          </a:xfrm>
+          <a:prstGeom prst="roundRect">
+            <a:avLst>
+              <a:gd name="adj" fmla="val 2609"/>
+            </a:avLst>
+          </a:prstGeom>
+          <a:solidFill>
+            <a:srgbClr val="FDF0EE"/>
+          </a:solidFill>
+          <a:ln w="9525">
+            <a:solidFill>
+              <a:srgbClr val="DCE5EC"/>
+            </a:solidFill>
+            <a:prstDash val="solid"/>
+          </a:ln>
+        </p:spPr>
+      </p:sp>
+      <p:sp>
+        <p:nvSpPr>
+          <p:cNvPr id="8" name="Text 6"/>
+          <p:cNvSpPr/>
+          <p:nvPr/>
+        </p:nvSpPr>
+        <p:spPr>
+          <a:xfrm>
+            <a:off x="6492240" y="1847088"/>
+            <a:ext cx="4754880" cy="329184"/>
+          </a:xfrm>
+          <a:prstGeom prst="rect">
+            <a:avLst/>
+          </a:prstGeom>
+          <a:noFill/>
+          <a:ln/>
+        </p:spPr>
+        <p:txBody>
+          <a:bodyPr wrap="square" lIns="0" tIns="0" rIns="0" bIns="0" rtlCol="0" anchor="ctr"/>
+          <a:lstStyle/>
+          <a:p>
+            <a:pPr indent="0" marL="0">
+              <a:buNone/>
+            </a:pPr>
+            <a:r>
+              <a:rPr lang="en-US" sz="1500" b="1" dirty="0">
+                <a:solidFill>
+                  <a:srgbClr val="C0392B"/>
+                </a:solidFill>
+                <a:latin typeface="Calibri" pitchFamily="34" charset="0"/>
+                <a:ea typeface="Calibri" pitchFamily="34" charset="-122"/>
+                <a:cs typeface="Calibri" pitchFamily="34" charset="-120"/>
+              </a:rPr>
+              <a:t>Why it matters</a:t>
+            </a:r>
+            <a:endParaRPr lang="en-US" sz="1500" dirty="0"/>
+          </a:p>
+        </p:txBody>
+      </p:sp>
+      <p:sp>
+        <p:nvSpPr>
+          <p:cNvPr id="9" name="Text 7"/>
+          <p:cNvSpPr/>
+          <p:nvPr/>
+        </p:nvSpPr>
+        <p:spPr>
+          <a:xfrm>
+            <a:off x="6492240" y="2249424"/>
+            <a:ext cx="4846320" cy="1280160"/>
+          </a:xfrm>
+          <a:prstGeom prst="rect">
+            <a:avLst/>
+          </a:prstGeom>
+          <a:noFill/>
+          <a:ln/>
+        </p:spPr>
+        <p:txBody>
+          <a:bodyPr wrap="square" lIns="0" tIns="0" rIns="0" bIns="0" rtlCol="0" anchor="ctr"/>
+          <a:lstStyle/>
+          <a:p>
+            <a:pPr indent="0" marL="0">
+              <a:buNone/>
+            </a:pPr>
+            <a:r>
+              <a:rPr lang="en-US" sz="1300" dirty="0">
+                <a:solidFill>
+                  <a:srgbClr val="16222E"/>
+                </a:solidFill>
+                <a:latin typeface="Calibri" pitchFamily="34" charset="0"/>
+                <a:ea typeface="Calibri" pitchFamily="34" charset="-122"/>
+                <a:cs typeface="Calibri" pitchFamily="34" charset="-120"/>
+              </a:rPr>
+              <a:t>One BRAM would have cost at least 100 penalty units — more than a third of the entire LUT budget of the submitted design — to store 512 bits.</a:t>
+            </a:r>
+            <a:endParaRPr lang="en-US" sz="1300" dirty="0"/>
+          </a:p>
+        </p:txBody>
+      </p:sp>
+      <p:sp>
+        <p:nvSpPr>
+          <p:cNvPr id="10" name="Text 8"/>
+          <p:cNvSpPr/>
+          <p:nvPr/>
+        </p:nvSpPr>
+        <p:spPr>
+          <a:xfrm>
+            <a:off x="548640" y="3968496"/>
+            <a:ext cx="5486400" cy="365760"/>
+          </a:xfrm>
+          <a:prstGeom prst="rect">
+            <a:avLst/>
+          </a:prstGeom>
+          <a:noFill/>
+          <a:ln/>
+        </p:spPr>
+        <p:txBody>
+          <a:bodyPr wrap="square" lIns="0" tIns="0" rIns="0" bIns="0" rtlCol="0" anchor="ctr"/>
+          <a:lstStyle/>
+          <a:p>
+            <a:pPr indent="0" marL="0">
+              <a:buNone/>
+            </a:pPr>
+            <a:r>
+              <a:rPr lang="en-US" sz="1600" b="1" dirty="0">
+                <a:solidFill>
+                  <a:srgbClr val="16222E"/>
+                </a:solidFill>
+                <a:latin typeface="Calibri" pitchFamily="34" charset="0"/>
+                <a:ea typeface="Calibri" pitchFamily="34" charset="-122"/>
+                <a:cs typeface="Calibri" pitchFamily="34" charset="-120"/>
+              </a:rPr>
+              <a:t>Power breakdown</a:t>
+            </a:r>
+            <a:endParaRPr lang="en-US" sz="1600" dirty="0"/>
+          </a:p>
+        </p:txBody>
+      </p:sp>
+      <p:graphicFrame>
+        <p:nvGraphicFramePr>
+          <p:cNvPr id="11" name="Chart 0" descr=""/>
+          <p:cNvGraphicFramePr/>
+          <p:nvPr/>
+        </p:nvGraphicFramePr>
+        <p:xfrm>
+          <a:off x="457200" y="4206240"/>
+          <a:ext cx="4023360" cy="2286000"/>
+        </p:xfrm>
+        <a:graphic xmlns:a="http://schemas.openxmlformats.org/drawingml/2006/main">
+          <a:graphicData uri="http://schemas.openxmlformats.org/drawingml/2006/chart">
+            <c:chart xmlns:c="http://schemas.openxmlformats.org/drawingml/2006/chart" r:id="rId1"/>
+          </a:graphicData>
+        </a:graphic>
+      </p:graphicFrame>
+      <p:sp>
+        <p:nvSpPr>
+          <p:cNvPr id="12" name="Shape 9"/>
+          <p:cNvSpPr/>
+          <p:nvPr/>
+        </p:nvSpPr>
+        <p:spPr>
+          <a:xfrm>
+            <a:off x="4846320" y="4370832"/>
+            <a:ext cx="6766560" cy="1920240"/>
+          </a:xfrm>
+          <a:prstGeom prst="roundRect">
+            <a:avLst>
+              <a:gd name="adj" fmla="val 2857"/>
+            </a:avLst>
+          </a:prstGeom>
+          <a:solidFill>
+            <a:srgbClr val="F3F8FB"/>
+          </a:solidFill>
+          <a:ln w="9525">
+            <a:solidFill>
+              <a:srgbClr val="DCE5EC"/>
+            </a:solidFill>
+            <a:prstDash val="solid"/>
+          </a:ln>
+        </p:spPr>
+      </p:sp>
+      <p:sp>
+        <p:nvSpPr>
+          <p:cNvPr id="13" name="Text 10"/>
+          <p:cNvSpPr/>
+          <p:nvPr/>
+        </p:nvSpPr>
+        <p:spPr>
+          <a:xfrm>
+            <a:off x="5120640" y="4572000"/>
+            <a:ext cx="6309360" cy="822960"/>
+          </a:xfrm>
+          <a:prstGeom prst="rect">
+            <a:avLst/>
+          </a:prstGeom>
+          <a:noFill/>
+          <a:ln/>
+        </p:spPr>
+        <p:txBody>
+          <a:bodyPr wrap="square" lIns="0" tIns="0" rIns="0" bIns="0" rtlCol="0" anchor="ctr"/>
+          <a:lstStyle/>
+          <a:p>
+            <a:pPr indent="0" marL="0">
+              <a:buNone/>
+            </a:pPr>
+            <a:r>
+              <a:rPr lang="en-US" sz="1300" dirty="0">
+                <a:solidFill>
+                  <a:srgbClr val="16222E"/>
+                </a:solidFill>
+                <a:latin typeface="Calibri" pitchFamily="34" charset="0"/>
+                <a:ea typeface="Calibri" pitchFamily="34" charset="-122"/>
+                <a:cs typeface="Calibri" pitchFamily="34" charset="-120"/>
+              </a:rPr>
+              <a:t>Only 21 mW of the 476 mW total is dynamic. The remaining 455 mW is static leakage inherent to the 65 nm Virtex-5 process and independent of the design — it is the same figure our earlier work measured on this board.</a:t>
+            </a:r>
+            <a:endParaRPr lang="en-US" sz="1300" dirty="0"/>
+          </a:p>
+        </p:txBody>
+      </p:sp>
+      <p:sp>
+        <p:nvSpPr>
+          <p:cNvPr id="14" name="Text 11"/>
+          <p:cNvSpPr/>
+          <p:nvPr/>
+        </p:nvSpPr>
+        <p:spPr>
+          <a:xfrm>
+            <a:off x="5120640" y="5413248"/>
+            <a:ext cx="6309360" cy="731520"/>
+          </a:xfrm>
+          <a:prstGeom prst="rect">
+            <a:avLst/>
+          </a:prstGeom>
+          <a:noFill/>
+          <a:ln/>
+        </p:spPr>
+        <p:txBody>
+          <a:bodyPr wrap="square" lIns="0" tIns="0" rIns="0" bIns="0" rtlCol="0" anchor="ctr"/>
+          <a:lstStyle/>
+          <a:p>
+            <a:pPr indent="0" marL="0">
+              <a:buNone/>
+            </a:pPr>
+            <a:r>
+              <a:rPr lang="en-US" sz="1250" i="1" dirty="0">
+                <a:solidFill>
+                  <a:srgbClr val="5C6B7A"/>
+                </a:solidFill>
+                <a:latin typeface="Calibri" pitchFamily="34" charset="0"/>
+                <a:ea typeface="Calibri" pitchFamily="34" charset="-122"/>
+                <a:cs typeface="Calibri" pitchFamily="34" charset="-120"/>
+              </a:rPr>
+              <a:t>Against dynamic power alone the FoM would be 5.52×10⁻², some 23× higher. We report total power as the official figure, as the conservative reading of the specification.</a:t>
+            </a:r>
+            <a:endParaRPr lang="en-US" sz="1250" dirty="0"/>
+          </a:p>
+        </p:txBody>
+      </p:sp>
+    </p:spTree>
+  </p:cSld>
+  <p:clrMapOvr>
+    <a:masterClrMapping/>
+  </p:clrMapOvr>
+</p:sld>
+</file>
+
+<file path=ppt/slides/slide12.xml><?xml version="1.0" encoding="utf-8"?>
+<p:sld xmlns:a="http://schemas.openxmlformats.org/drawingml/2006/main" xmlns:r="http://schemas.openxmlformats.org/officeDocument/2006/relationships" xmlns:p="http://schemas.openxmlformats.org/presentationml/2006/main">
+  <p:cSld name="Slide 12">
+    <p:bg>
+      <p:bgPr>
+        <a:solidFill>
+          <a:srgbClr val="FFFFFF"/>
+        </a:solidFill>
+      </p:bgPr>
+    </p:bg>
+    <p:spTree>
+      <p:nvGrpSpPr>
+        <p:cNvPr id="1" name=""/>
+        <p:cNvGrpSpPr/>
+        <p:nvPr/>
+      </p:nvGrpSpPr>
+      <p:grpSpPr>
+        <a:xfrm>
+          <a:off x="0" y="0"/>
+          <a:ext cx="0" cy="0"/>
+          <a:chOff x="0" y="0"/>
+          <a:chExt cx="0" cy="0"/>
+        </a:xfrm>
+      </p:grpSpPr>
+      <p:sp>
+        <p:nvSpPr>
+          <p:cNvPr id="2" name="Text 0"/>
+          <p:cNvSpPr/>
+          <p:nvPr/>
+        </p:nvSpPr>
+        <p:spPr>
+          <a:xfrm>
+            <a:off x="548640" y="384048"/>
+            <a:ext cx="11064240" cy="237744"/>
+          </a:xfrm>
+          <a:prstGeom prst="rect">
+            <a:avLst/>
+          </a:prstGeom>
+          <a:noFill/>
+          <a:ln/>
+        </p:spPr>
+        <p:txBody>
+          <a:bodyPr wrap="square" lIns="0" tIns="0" rIns="0" bIns="0" rtlCol="0" anchor="ctr"/>
+          <a:lstStyle/>
+          <a:p>
+            <a:pPr indent="0" marL="0">
+              <a:buNone/>
+            </a:pPr>
+            <a:r>
+              <a:rPr lang="en-US" sz="1100" b="1" spc="200" kern="0" dirty="0">
+                <a:solidFill>
+                  <a:srgbClr val="1C7293"/>
+                </a:solidFill>
+                <a:latin typeface="Calibri" pitchFamily="34" charset="0"/>
+                <a:ea typeface="Calibri" pitchFamily="34" charset="-122"/>
+                <a:cs typeface="Calibri" pitchFamily="34" charset="-120"/>
+              </a:rPr>
+              <a:t>POST-PLACE-AND-ROUTE, BOTH BUILDS</a:t>
             </a:r>
             <a:endParaRPr lang="en-US" sz="1100" dirty="0"/>
           </a:p>
@@ -2873,7 +3504,7 @@
       </p:sp>
       <p:graphicFrame>
         <p:nvGraphicFramePr>
-          <p:cNvPr id="12" name="Table 0"/>
+          <p:cNvPr id="13" name="Table 0"/>
           <p:cNvGraphicFramePr>
             <a:graphicFrameLocks noGrp="1"/>
           </p:cNvGraphicFramePr>
@@ -2985,7 +3616,7 @@
                           <a:ea typeface="Calibri" pitchFamily="34" charset="-122"/>
                           <a:cs typeface="Calibri" pitchFamily="34" charset="-120"/>
                         </a:rPr>
-                        <a:t>Specification</a:t>
+                        <a:t>VALID (primary)</a:t>
                       </a:r>
                       <a:endParaRPr lang="en-US" sz="1100" dirty="0">
                         <a:latin typeface="Calibri" charset="0"/>
@@ -3053,7 +3684,7 @@
                           <a:ea typeface="Calibri" pitchFamily="34" charset="-122"/>
                           <a:cs typeface="Calibri" pitchFamily="34" charset="-120"/>
                         </a:rPr>
-                        <a:t>Team result</a:t>
+                        <a:t>SAME (zero-gap bonus)</a:t>
                       </a:r>
                       <a:endParaRPr lang="en-US" sz="1100" dirty="0">
                         <a:latin typeface="Calibri" charset="0"/>
@@ -3191,7 +3822,7 @@
                           <a:ea typeface="Calibri" pitchFamily="34" charset="-122"/>
                           <a:cs typeface="Calibri" pitchFamily="34" charset="-120"/>
                         </a:rPr>
-                        <a:t>Input image size</a:t>
+                        <a:t>Input / output precision</a:t>
                       </a:r>
                       <a:endParaRPr lang="en-US" sz="1100" dirty="0">
                         <a:latin typeface="Calibri" charset="0"/>
@@ -3259,7 +3890,7 @@
                           <a:ea typeface="Calibri" pitchFamily="34" charset="-122"/>
                           <a:cs typeface="Calibri" pitchFamily="34" charset="-120"/>
                         </a:rPr>
-                        <a:t>≥ 32 × 32</a:t>
+                        <a:t>8 / 16, saturating</a:t>
                       </a:r>
                       <a:endParaRPr lang="en-US" sz="1100" dirty="0">
                         <a:latin typeface="Calibri" charset="0"/>
@@ -3327,281 +3958,7 @@
                           <a:ea typeface="Calibri" pitchFamily="34" charset="-122"/>
                           <a:cs typeface="Calibri" pitchFamily="34" charset="-120"/>
                         </a:rPr>
-                        <a:t>32 × 32</a:t>
-                      </a:r>
-                      <a:endParaRPr lang="en-US" sz="1100" dirty="0">
-                        <a:latin typeface="Calibri" charset="0"/>
-                        <a:ea typeface="Calibri" charset="0"/>
-                        <a:cs typeface="Calibri" charset="0"/>
-                      </a:endParaRPr>
-                    </a:p>
-                  </a:txBody>
-                  <a:tcPr marL="91440" marR="91440" marT="45720" marB="45720" anchor="ctr">
-                    <a:lnL w="7620" cap="flat" cmpd="sng" algn="ctr">
-                      <a:solidFill>
-                        <a:srgbClr val="DCE5EC"/>
-                      </a:solidFill>
-                      <a:prstDash val="solid"/>
-                      <a:round/>
-                      <a:headEnd type="none" w="med" len="med"/>
-                      <a:tailEnd type="none" w="med" len="med"/>
-                    </a:lnL>
-                    <a:lnR w="7620" cap="flat" cmpd="sng" algn="ctr">
-                      <a:solidFill>
-                        <a:srgbClr val="DCE5EC"/>
-                      </a:solidFill>
-                      <a:prstDash val="solid"/>
-                      <a:round/>
-                      <a:headEnd type="none" w="med" len="med"/>
-                      <a:tailEnd type="none" w="med" len="med"/>
-                    </a:lnR>
-                    <a:lnT w="7620" cap="flat" cmpd="sng" algn="ctr">
-                      <a:solidFill>
-                        <a:srgbClr val="DCE5EC"/>
-                      </a:solidFill>
-                      <a:prstDash val="solid"/>
-                      <a:round/>
-                      <a:headEnd type="none" w="med" len="med"/>
-                      <a:tailEnd type="none" w="med" len="med"/>
-                    </a:lnT>
-                    <a:lnB w="7620" cap="flat" cmpd="sng" algn="ctr">
-                      <a:solidFill>
-                        <a:srgbClr val="DCE5EC"/>
-                      </a:solidFill>
-                      <a:prstDash val="solid"/>
-                      <a:round/>
-                      <a:headEnd type="none" w="med" len="med"/>
-                      <a:tailEnd type="none" w="med" len="med"/>
-                    </a:lnB>
-                    <a:solidFill>
-                      <a:srgbClr val="FFFFFF"/>
-                    </a:solidFill>
-                  </a:tcPr>
-                </a:tc>
-                <a:tc>
-                  <a:txBody>
-                    <a:bodyPr/>
-                    <a:lstStyle/>
-                    <a:p>
-                      <a:pPr algn="l" indent="0" marL="0">
-                        <a:buNone/>
-                      </a:pPr>
-                      <a:r>
-                        <a:rPr lang="en-US" sz="1100" dirty="0">
-                          <a:solidFill>
-                            <a:srgbClr val="16222E"/>
-                          </a:solidFill>
-                          <a:latin typeface="Calibri" pitchFamily="34" charset="0"/>
-                          <a:ea typeface="Calibri" pitchFamily="34" charset="-122"/>
-                          <a:cs typeface="Calibri" pitchFamily="34" charset="-120"/>
-                        </a:rPr>
-                        <a:t>pixels</a:t>
-                      </a:r>
-                      <a:endParaRPr lang="en-US" sz="1100" dirty="0">
-                        <a:latin typeface="Calibri" charset="0"/>
-                        <a:ea typeface="Calibri" charset="0"/>
-                        <a:cs typeface="Calibri" charset="0"/>
-                      </a:endParaRPr>
-                    </a:p>
-                  </a:txBody>
-                  <a:tcPr marL="91440" marR="91440" marT="45720" marB="45720" anchor="ctr">
-                    <a:lnL w="7620" cap="flat" cmpd="sng" algn="ctr">
-                      <a:solidFill>
-                        <a:srgbClr val="DCE5EC"/>
-                      </a:solidFill>
-                      <a:prstDash val="solid"/>
-                      <a:round/>
-                      <a:headEnd type="none" w="med" len="med"/>
-                      <a:tailEnd type="none" w="med" len="med"/>
-                    </a:lnL>
-                    <a:lnR w="7620" cap="flat" cmpd="sng" algn="ctr">
-                      <a:solidFill>
-                        <a:srgbClr val="DCE5EC"/>
-                      </a:solidFill>
-                      <a:prstDash val="solid"/>
-                      <a:round/>
-                      <a:headEnd type="none" w="med" len="med"/>
-                      <a:tailEnd type="none" w="med" len="med"/>
-                    </a:lnR>
-                    <a:lnT w="7620" cap="flat" cmpd="sng" algn="ctr">
-                      <a:solidFill>
-                        <a:srgbClr val="DCE5EC"/>
-                      </a:solidFill>
-                      <a:prstDash val="solid"/>
-                      <a:round/>
-                      <a:headEnd type="none" w="med" len="med"/>
-                      <a:tailEnd type="none" w="med" len="med"/>
-                    </a:lnT>
-                    <a:lnB w="7620" cap="flat" cmpd="sng" algn="ctr">
-                      <a:solidFill>
-                        <a:srgbClr val="DCE5EC"/>
-                      </a:solidFill>
-                      <a:prstDash val="solid"/>
-                      <a:round/>
-                      <a:headEnd type="none" w="med" len="med"/>
-                      <a:tailEnd type="none" w="med" len="med"/>
-                    </a:lnB>
-                    <a:solidFill>
-                      <a:srgbClr val="FFFFFF"/>
-                    </a:solidFill>
-                  </a:tcPr>
-                </a:tc>
-              </a:tr>
-              <a:tr h="265176">
-                <a:tc>
-                  <a:txBody>
-                    <a:bodyPr/>
-                    <a:lstStyle/>
-                    <a:p>
-                      <a:pPr algn="l" indent="0" marL="0">
-                        <a:buNone/>
-                      </a:pPr>
-                      <a:r>
-                        <a:rPr lang="en-US" sz="1100" dirty="0">
-                          <a:solidFill>
-                            <a:srgbClr val="16222E"/>
-                          </a:solidFill>
-                          <a:latin typeface="Calibri" pitchFamily="34" charset="0"/>
-                          <a:ea typeface="Calibri" pitchFamily="34" charset="-122"/>
-                          <a:cs typeface="Calibri" pitchFamily="34" charset="-120"/>
-                        </a:rPr>
-                        <a:t>Input precision</a:t>
-                      </a:r>
-                      <a:endParaRPr lang="en-US" sz="1100" dirty="0">
-                        <a:latin typeface="Calibri" charset="0"/>
-                        <a:ea typeface="Calibri" charset="0"/>
-                        <a:cs typeface="Calibri" charset="0"/>
-                      </a:endParaRPr>
-                    </a:p>
-                  </a:txBody>
-                  <a:tcPr marL="91440" marR="91440" marT="45720" marB="45720" anchor="ctr">
-                    <a:lnL w="7620" cap="flat" cmpd="sng" algn="ctr">
-                      <a:solidFill>
-                        <a:srgbClr val="DCE5EC"/>
-                      </a:solidFill>
-                      <a:prstDash val="solid"/>
-                      <a:round/>
-                      <a:headEnd type="none" w="med" len="med"/>
-                      <a:tailEnd type="none" w="med" len="med"/>
-                    </a:lnL>
-                    <a:lnR w="7620" cap="flat" cmpd="sng" algn="ctr">
-                      <a:solidFill>
-                        <a:srgbClr val="DCE5EC"/>
-                      </a:solidFill>
-                      <a:prstDash val="solid"/>
-                      <a:round/>
-                      <a:headEnd type="none" w="med" len="med"/>
-                      <a:tailEnd type="none" w="med" len="med"/>
-                    </a:lnR>
-                    <a:lnT w="7620" cap="flat" cmpd="sng" algn="ctr">
-                      <a:solidFill>
-                        <a:srgbClr val="DCE5EC"/>
-                      </a:solidFill>
-                      <a:prstDash val="solid"/>
-                      <a:round/>
-                      <a:headEnd type="none" w="med" len="med"/>
-                      <a:tailEnd type="none" w="med" len="med"/>
-                    </a:lnT>
-                    <a:lnB w="7620" cap="flat" cmpd="sng" algn="ctr">
-                      <a:solidFill>
-                        <a:srgbClr val="DCE5EC"/>
-                      </a:solidFill>
-                      <a:prstDash val="solid"/>
-                      <a:round/>
-                      <a:headEnd type="none" w="med" len="med"/>
-                      <a:tailEnd type="none" w="med" len="med"/>
-                    </a:lnB>
-                    <a:solidFill>
-                      <a:srgbClr val="FFFFFF"/>
-                    </a:solidFill>
-                  </a:tcPr>
-                </a:tc>
-                <a:tc>
-                  <a:txBody>
-                    <a:bodyPr/>
-                    <a:lstStyle/>
-                    <a:p>
-                      <a:pPr algn="l" indent="0" marL="0">
-                        <a:buNone/>
-                      </a:pPr>
-                      <a:r>
-                        <a:rPr lang="en-US" sz="1100" dirty="0">
-                          <a:solidFill>
-                            <a:srgbClr val="16222E"/>
-                          </a:solidFill>
-                          <a:latin typeface="Calibri" pitchFamily="34" charset="0"/>
-                          <a:ea typeface="Calibri" pitchFamily="34" charset="-122"/>
-                          <a:cs typeface="Calibri" pitchFamily="34" charset="-120"/>
-                        </a:rPr>
-                        <a:t>Fixed-point unsigned</a:t>
-                      </a:r>
-                      <a:endParaRPr lang="en-US" sz="1100" dirty="0">
-                        <a:latin typeface="Calibri" charset="0"/>
-                        <a:ea typeface="Calibri" charset="0"/>
-                        <a:cs typeface="Calibri" charset="0"/>
-                      </a:endParaRPr>
-                    </a:p>
-                  </a:txBody>
-                  <a:tcPr marL="91440" marR="91440" marT="45720" marB="45720" anchor="ctr">
-                    <a:lnL w="7620" cap="flat" cmpd="sng" algn="ctr">
-                      <a:solidFill>
-                        <a:srgbClr val="DCE5EC"/>
-                      </a:solidFill>
-                      <a:prstDash val="solid"/>
-                      <a:round/>
-                      <a:headEnd type="none" w="med" len="med"/>
-                      <a:tailEnd type="none" w="med" len="med"/>
-                    </a:lnL>
-                    <a:lnR w="7620" cap="flat" cmpd="sng" algn="ctr">
-                      <a:solidFill>
-                        <a:srgbClr val="DCE5EC"/>
-                      </a:solidFill>
-                      <a:prstDash val="solid"/>
-                      <a:round/>
-                      <a:headEnd type="none" w="med" len="med"/>
-                      <a:tailEnd type="none" w="med" len="med"/>
-                    </a:lnR>
-                    <a:lnT w="7620" cap="flat" cmpd="sng" algn="ctr">
-                      <a:solidFill>
-                        <a:srgbClr val="DCE5EC"/>
-                      </a:solidFill>
-                      <a:prstDash val="solid"/>
-                      <a:round/>
-                      <a:headEnd type="none" w="med" len="med"/>
-                      <a:tailEnd type="none" w="med" len="med"/>
-                    </a:lnT>
-                    <a:lnB w="7620" cap="flat" cmpd="sng" algn="ctr">
-                      <a:solidFill>
-                        <a:srgbClr val="DCE5EC"/>
-                      </a:solidFill>
-                      <a:prstDash val="solid"/>
-                      <a:round/>
-                      <a:headEnd type="none" w="med" len="med"/>
-                      <a:tailEnd type="none" w="med" len="med"/>
-                    </a:lnB>
-                    <a:solidFill>
-                      <a:srgbClr val="FFFFFF"/>
-                    </a:solidFill>
-                  </a:tcPr>
-                </a:tc>
-                <a:tc>
-                  <a:txBody>
-                    <a:bodyPr/>
-                    <a:lstStyle/>
-                    <a:p>
-                      <a:pPr algn="l" indent="0" marL="0">
-                        <a:buNone/>
-                      </a:pPr>
-                      <a:r>
-                        <a:rPr lang="en-US" sz="1100" dirty="0">
-                          <a:solidFill>
-                            <a:srgbClr val="16222E"/>
-                          </a:solidFill>
-                          <a:latin typeface="Calibri" pitchFamily="34" charset="0"/>
-                          <a:ea typeface="Calibri" pitchFamily="34" charset="-122"/>
-                          <a:cs typeface="Calibri" pitchFamily="34" charset="-120"/>
-                        </a:rPr>
-                        <a:t>8</a:t>
+                        <a:t>8 / 16, saturating</a:t>
                       </a:r>
                       <a:endParaRPr lang="en-US" sz="1100" dirty="0">
                         <a:latin typeface="Calibri" charset="0"/>
@@ -3739,7 +4096,7 @@
                           <a:ea typeface="Calibri" pitchFamily="34" charset="-122"/>
                           <a:cs typeface="Calibri" pitchFamily="34" charset="-120"/>
                         </a:rPr>
-                        <a:t>Kernel precision</a:t>
+                        <a:t>Architecture</a:t>
                       </a:r>
                       <a:endParaRPr lang="en-US" sz="1100" dirty="0">
                         <a:latin typeface="Calibri" charset="0"/>
@@ -3807,7 +4164,7 @@
                           <a:ea typeface="Calibri" pitchFamily="34" charset="-122"/>
                           <a:cs typeface="Calibri" pitchFamily="34" charset="-120"/>
                         </a:rPr>
-                        <a:t>8-bit signed</a:t>
+                        <a:t>Line-buffer sliding window</a:t>
                       </a:r>
                       <a:endParaRPr lang="en-US" sz="1100" dirty="0">
                         <a:latin typeface="Calibri" charset="0"/>
@@ -3875,555 +4232,7 @@
                           <a:ea typeface="Calibri" pitchFamily="34" charset="-122"/>
                           <a:cs typeface="Calibri" pitchFamily="34" charset="-120"/>
                         </a:rPr>
-                        <a:t>8, programmable</a:t>
-                      </a:r>
-                      <a:endParaRPr lang="en-US" sz="1100" dirty="0">
-                        <a:latin typeface="Calibri" charset="0"/>
-                        <a:ea typeface="Calibri" charset="0"/>
-                        <a:cs typeface="Calibri" charset="0"/>
-                      </a:endParaRPr>
-                    </a:p>
-                  </a:txBody>
-                  <a:tcPr marL="91440" marR="91440" marT="45720" marB="45720" anchor="ctr">
-                    <a:lnL w="7620" cap="flat" cmpd="sng" algn="ctr">
-                      <a:solidFill>
-                        <a:srgbClr val="DCE5EC"/>
-                      </a:solidFill>
-                      <a:prstDash val="solid"/>
-                      <a:round/>
-                      <a:headEnd type="none" w="med" len="med"/>
-                      <a:tailEnd type="none" w="med" len="med"/>
-                    </a:lnL>
-                    <a:lnR w="7620" cap="flat" cmpd="sng" algn="ctr">
-                      <a:solidFill>
-                        <a:srgbClr val="DCE5EC"/>
-                      </a:solidFill>
-                      <a:prstDash val="solid"/>
-                      <a:round/>
-                      <a:headEnd type="none" w="med" len="med"/>
-                      <a:tailEnd type="none" w="med" len="med"/>
-                    </a:lnR>
-                    <a:lnT w="7620" cap="flat" cmpd="sng" algn="ctr">
-                      <a:solidFill>
-                        <a:srgbClr val="DCE5EC"/>
-                      </a:solidFill>
-                      <a:prstDash val="solid"/>
-                      <a:round/>
-                      <a:headEnd type="none" w="med" len="med"/>
-                      <a:tailEnd type="none" w="med" len="med"/>
-                    </a:lnT>
-                    <a:lnB w="7620" cap="flat" cmpd="sng" algn="ctr">
-                      <a:solidFill>
-                        <a:srgbClr val="DCE5EC"/>
-                      </a:solidFill>
-                      <a:prstDash val="solid"/>
-                      <a:round/>
-                      <a:headEnd type="none" w="med" len="med"/>
-                      <a:tailEnd type="none" w="med" len="med"/>
-                    </a:lnB>
-                    <a:solidFill>
-                      <a:srgbClr val="FFFFFF"/>
-                    </a:solidFill>
-                  </a:tcPr>
-                </a:tc>
-                <a:tc>
-                  <a:txBody>
-                    <a:bodyPr/>
-                    <a:lstStyle/>
-                    <a:p>
-                      <a:pPr algn="l" indent="0" marL="0">
-                        <a:buNone/>
-                      </a:pPr>
-                      <a:r>
-                        <a:rPr lang="en-US" sz="1100" dirty="0">
-                          <a:solidFill>
-                            <a:srgbClr val="16222E"/>
-                          </a:solidFill>
-                          <a:latin typeface="Calibri" pitchFamily="34" charset="0"/>
-                          <a:ea typeface="Calibri" pitchFamily="34" charset="-122"/>
-                          <a:cs typeface="Calibri" pitchFamily="34" charset="-120"/>
-                        </a:rPr>
-                        <a:t>bits</a:t>
-                      </a:r>
-                      <a:endParaRPr lang="en-US" sz="1100" dirty="0">
-                        <a:latin typeface="Calibri" charset="0"/>
-                        <a:ea typeface="Calibri" charset="0"/>
-                        <a:cs typeface="Calibri" charset="0"/>
-                      </a:endParaRPr>
-                    </a:p>
-                  </a:txBody>
-                  <a:tcPr marL="91440" marR="91440" marT="45720" marB="45720" anchor="ctr">
-                    <a:lnL w="7620" cap="flat" cmpd="sng" algn="ctr">
-                      <a:solidFill>
-                        <a:srgbClr val="DCE5EC"/>
-                      </a:solidFill>
-                      <a:prstDash val="solid"/>
-                      <a:round/>
-                      <a:headEnd type="none" w="med" len="med"/>
-                      <a:tailEnd type="none" w="med" len="med"/>
-                    </a:lnL>
-                    <a:lnR w="7620" cap="flat" cmpd="sng" algn="ctr">
-                      <a:solidFill>
-                        <a:srgbClr val="DCE5EC"/>
-                      </a:solidFill>
-                      <a:prstDash val="solid"/>
-                      <a:round/>
-                      <a:headEnd type="none" w="med" len="med"/>
-                      <a:tailEnd type="none" w="med" len="med"/>
-                    </a:lnR>
-                    <a:lnT w="7620" cap="flat" cmpd="sng" algn="ctr">
-                      <a:solidFill>
-                        <a:srgbClr val="DCE5EC"/>
-                      </a:solidFill>
-                      <a:prstDash val="solid"/>
-                      <a:round/>
-                      <a:headEnd type="none" w="med" len="med"/>
-                      <a:tailEnd type="none" w="med" len="med"/>
-                    </a:lnT>
-                    <a:lnB w="7620" cap="flat" cmpd="sng" algn="ctr">
-                      <a:solidFill>
-                        <a:srgbClr val="DCE5EC"/>
-                      </a:solidFill>
-                      <a:prstDash val="solid"/>
-                      <a:round/>
-                      <a:headEnd type="none" w="med" len="med"/>
-                      <a:tailEnd type="none" w="med" len="med"/>
-                    </a:lnB>
-                    <a:solidFill>
-                      <a:srgbClr val="FFFFFF"/>
-                    </a:solidFill>
-                  </a:tcPr>
-                </a:tc>
-              </a:tr>
-              <a:tr h="265176">
-                <a:tc>
-                  <a:txBody>
-                    <a:bodyPr/>
-                    <a:lstStyle/>
-                    <a:p>
-                      <a:pPr algn="l" indent="0" marL="0">
-                        <a:buNone/>
-                      </a:pPr>
-                      <a:r>
-                        <a:rPr lang="en-US" sz="1100" dirty="0">
-                          <a:solidFill>
-                            <a:srgbClr val="16222E"/>
-                          </a:solidFill>
-                          <a:latin typeface="Calibri" pitchFamily="34" charset="0"/>
-                          <a:ea typeface="Calibri" pitchFamily="34" charset="-122"/>
-                          <a:cs typeface="Calibri" pitchFamily="34" charset="-120"/>
-                        </a:rPr>
-                        <a:t>Output precision</a:t>
-                      </a:r>
-                      <a:endParaRPr lang="en-US" sz="1100" dirty="0">
-                        <a:latin typeface="Calibri" charset="0"/>
-                        <a:ea typeface="Calibri" charset="0"/>
-                        <a:cs typeface="Calibri" charset="0"/>
-                      </a:endParaRPr>
-                    </a:p>
-                  </a:txBody>
-                  <a:tcPr marL="91440" marR="91440" marT="45720" marB="45720" anchor="ctr">
-                    <a:lnL w="7620" cap="flat" cmpd="sng" algn="ctr">
-                      <a:solidFill>
-                        <a:srgbClr val="DCE5EC"/>
-                      </a:solidFill>
-                      <a:prstDash val="solid"/>
-                      <a:round/>
-                      <a:headEnd type="none" w="med" len="med"/>
-                      <a:tailEnd type="none" w="med" len="med"/>
-                    </a:lnL>
-                    <a:lnR w="7620" cap="flat" cmpd="sng" algn="ctr">
-                      <a:solidFill>
-                        <a:srgbClr val="DCE5EC"/>
-                      </a:solidFill>
-                      <a:prstDash val="solid"/>
-                      <a:round/>
-                      <a:headEnd type="none" w="med" len="med"/>
-                      <a:tailEnd type="none" w="med" len="med"/>
-                    </a:lnR>
-                    <a:lnT w="7620" cap="flat" cmpd="sng" algn="ctr">
-                      <a:solidFill>
-                        <a:srgbClr val="DCE5EC"/>
-                      </a:solidFill>
-                      <a:prstDash val="solid"/>
-                      <a:round/>
-                      <a:headEnd type="none" w="med" len="med"/>
-                      <a:tailEnd type="none" w="med" len="med"/>
-                    </a:lnT>
-                    <a:lnB w="7620" cap="flat" cmpd="sng" algn="ctr">
-                      <a:solidFill>
-                        <a:srgbClr val="DCE5EC"/>
-                      </a:solidFill>
-                      <a:prstDash val="solid"/>
-                      <a:round/>
-                      <a:headEnd type="none" w="med" len="med"/>
-                      <a:tailEnd type="none" w="med" len="med"/>
-                    </a:lnB>
-                    <a:solidFill>
-                      <a:srgbClr val="FFFFFF"/>
-                    </a:solidFill>
-                  </a:tcPr>
-                </a:tc>
-                <a:tc>
-                  <a:txBody>
-                    <a:bodyPr/>
-                    <a:lstStyle/>
-                    <a:p>
-                      <a:pPr algn="l" indent="0" marL="0">
-                        <a:buNone/>
-                      </a:pPr>
-                      <a:r>
-                        <a:rPr lang="en-US" sz="1100" dirty="0">
-                          <a:solidFill>
-                            <a:srgbClr val="16222E"/>
-                          </a:solidFill>
-                          <a:latin typeface="Calibri" pitchFamily="34" charset="0"/>
-                          <a:ea typeface="Calibri" pitchFamily="34" charset="-122"/>
-                          <a:cs typeface="Calibri" pitchFamily="34" charset="-120"/>
-                        </a:rPr>
-                        <a:t>≥ 16-bit signed</a:t>
-                      </a:r>
-                      <a:endParaRPr lang="en-US" sz="1100" dirty="0">
-                        <a:latin typeface="Calibri" charset="0"/>
-                        <a:ea typeface="Calibri" charset="0"/>
-                        <a:cs typeface="Calibri" charset="0"/>
-                      </a:endParaRPr>
-                    </a:p>
-                  </a:txBody>
-                  <a:tcPr marL="91440" marR="91440" marT="45720" marB="45720" anchor="ctr">
-                    <a:lnL w="7620" cap="flat" cmpd="sng" algn="ctr">
-                      <a:solidFill>
-                        <a:srgbClr val="DCE5EC"/>
-                      </a:solidFill>
-                      <a:prstDash val="solid"/>
-                      <a:round/>
-                      <a:headEnd type="none" w="med" len="med"/>
-                      <a:tailEnd type="none" w="med" len="med"/>
-                    </a:lnL>
-                    <a:lnR w="7620" cap="flat" cmpd="sng" algn="ctr">
-                      <a:solidFill>
-                        <a:srgbClr val="DCE5EC"/>
-                      </a:solidFill>
-                      <a:prstDash val="solid"/>
-                      <a:round/>
-                      <a:headEnd type="none" w="med" len="med"/>
-                      <a:tailEnd type="none" w="med" len="med"/>
-                    </a:lnR>
-                    <a:lnT w="7620" cap="flat" cmpd="sng" algn="ctr">
-                      <a:solidFill>
-                        <a:srgbClr val="DCE5EC"/>
-                      </a:solidFill>
-                      <a:prstDash val="solid"/>
-                      <a:round/>
-                      <a:headEnd type="none" w="med" len="med"/>
-                      <a:tailEnd type="none" w="med" len="med"/>
-                    </a:lnT>
-                    <a:lnB w="7620" cap="flat" cmpd="sng" algn="ctr">
-                      <a:solidFill>
-                        <a:srgbClr val="DCE5EC"/>
-                      </a:solidFill>
-                      <a:prstDash val="solid"/>
-                      <a:round/>
-                      <a:headEnd type="none" w="med" len="med"/>
-                      <a:tailEnd type="none" w="med" len="med"/>
-                    </a:lnB>
-                    <a:solidFill>
-                      <a:srgbClr val="FFFFFF"/>
-                    </a:solidFill>
-                  </a:tcPr>
-                </a:tc>
-                <a:tc>
-                  <a:txBody>
-                    <a:bodyPr/>
-                    <a:lstStyle/>
-                    <a:p>
-                      <a:pPr algn="l" indent="0" marL="0">
-                        <a:buNone/>
-                      </a:pPr>
-                      <a:r>
-                        <a:rPr lang="en-US" sz="1100" dirty="0">
-                          <a:solidFill>
-                            <a:srgbClr val="16222E"/>
-                          </a:solidFill>
-                          <a:latin typeface="Calibri" pitchFamily="34" charset="0"/>
-                          <a:ea typeface="Calibri" pitchFamily="34" charset="-122"/>
-                          <a:cs typeface="Calibri" pitchFamily="34" charset="-120"/>
-                        </a:rPr>
-                        <a:t>16, saturating</a:t>
-                      </a:r>
-                      <a:endParaRPr lang="en-US" sz="1100" dirty="0">
-                        <a:latin typeface="Calibri" charset="0"/>
-                        <a:ea typeface="Calibri" charset="0"/>
-                        <a:cs typeface="Calibri" charset="0"/>
-                      </a:endParaRPr>
-                    </a:p>
-                  </a:txBody>
-                  <a:tcPr marL="91440" marR="91440" marT="45720" marB="45720" anchor="ctr">
-                    <a:lnL w="7620" cap="flat" cmpd="sng" algn="ctr">
-                      <a:solidFill>
-                        <a:srgbClr val="DCE5EC"/>
-                      </a:solidFill>
-                      <a:prstDash val="solid"/>
-                      <a:round/>
-                      <a:headEnd type="none" w="med" len="med"/>
-                      <a:tailEnd type="none" w="med" len="med"/>
-                    </a:lnL>
-                    <a:lnR w="7620" cap="flat" cmpd="sng" algn="ctr">
-                      <a:solidFill>
-                        <a:srgbClr val="DCE5EC"/>
-                      </a:solidFill>
-                      <a:prstDash val="solid"/>
-                      <a:round/>
-                      <a:headEnd type="none" w="med" len="med"/>
-                      <a:tailEnd type="none" w="med" len="med"/>
-                    </a:lnR>
-                    <a:lnT w="7620" cap="flat" cmpd="sng" algn="ctr">
-                      <a:solidFill>
-                        <a:srgbClr val="DCE5EC"/>
-                      </a:solidFill>
-                      <a:prstDash val="solid"/>
-                      <a:round/>
-                      <a:headEnd type="none" w="med" len="med"/>
-                      <a:tailEnd type="none" w="med" len="med"/>
-                    </a:lnT>
-                    <a:lnB w="7620" cap="flat" cmpd="sng" algn="ctr">
-                      <a:solidFill>
-                        <a:srgbClr val="DCE5EC"/>
-                      </a:solidFill>
-                      <a:prstDash val="solid"/>
-                      <a:round/>
-                      <a:headEnd type="none" w="med" len="med"/>
-                      <a:tailEnd type="none" w="med" len="med"/>
-                    </a:lnB>
-                    <a:solidFill>
-                      <a:srgbClr val="FFFFFF"/>
-                    </a:solidFill>
-                  </a:tcPr>
-                </a:tc>
-                <a:tc>
-                  <a:txBody>
-                    <a:bodyPr/>
-                    <a:lstStyle/>
-                    <a:p>
-                      <a:pPr algn="l" indent="0" marL="0">
-                        <a:buNone/>
-                      </a:pPr>
-                      <a:r>
-                        <a:rPr lang="en-US" sz="1100" dirty="0">
-                          <a:solidFill>
-                            <a:srgbClr val="16222E"/>
-                          </a:solidFill>
-                          <a:latin typeface="Calibri" pitchFamily="34" charset="0"/>
-                          <a:ea typeface="Calibri" pitchFamily="34" charset="-122"/>
-                          <a:cs typeface="Calibri" pitchFamily="34" charset="-120"/>
-                        </a:rPr>
-                        <a:t>bits</a:t>
-                      </a:r>
-                      <a:endParaRPr lang="en-US" sz="1100" dirty="0">
-                        <a:latin typeface="Calibri" charset="0"/>
-                        <a:ea typeface="Calibri" charset="0"/>
-                        <a:cs typeface="Calibri" charset="0"/>
-                      </a:endParaRPr>
-                    </a:p>
-                  </a:txBody>
-                  <a:tcPr marL="91440" marR="91440" marT="45720" marB="45720" anchor="ctr">
-                    <a:lnL w="7620" cap="flat" cmpd="sng" algn="ctr">
-                      <a:solidFill>
-                        <a:srgbClr val="DCE5EC"/>
-                      </a:solidFill>
-                      <a:prstDash val="solid"/>
-                      <a:round/>
-                      <a:headEnd type="none" w="med" len="med"/>
-                      <a:tailEnd type="none" w="med" len="med"/>
-                    </a:lnL>
-                    <a:lnR w="7620" cap="flat" cmpd="sng" algn="ctr">
-                      <a:solidFill>
-                        <a:srgbClr val="DCE5EC"/>
-                      </a:solidFill>
-                      <a:prstDash val="solid"/>
-                      <a:round/>
-                      <a:headEnd type="none" w="med" len="med"/>
-                      <a:tailEnd type="none" w="med" len="med"/>
-                    </a:lnR>
-                    <a:lnT w="7620" cap="flat" cmpd="sng" algn="ctr">
-                      <a:solidFill>
-                        <a:srgbClr val="DCE5EC"/>
-                      </a:solidFill>
-                      <a:prstDash val="solid"/>
-                      <a:round/>
-                      <a:headEnd type="none" w="med" len="med"/>
-                      <a:tailEnd type="none" w="med" len="med"/>
-                    </a:lnT>
-                    <a:lnB w="7620" cap="flat" cmpd="sng" algn="ctr">
-                      <a:solidFill>
-                        <a:srgbClr val="DCE5EC"/>
-                      </a:solidFill>
-                      <a:prstDash val="solid"/>
-                      <a:round/>
-                      <a:headEnd type="none" w="med" len="med"/>
-                      <a:tailEnd type="none" w="med" len="med"/>
-                    </a:lnB>
-                    <a:solidFill>
-                      <a:srgbClr val="FFFFFF"/>
-                    </a:solidFill>
-                  </a:tcPr>
-                </a:tc>
-              </a:tr>
-              <a:tr h="265176">
-                <a:tc>
-                  <a:txBody>
-                    <a:bodyPr/>
-                    <a:lstStyle/>
-                    <a:p>
-                      <a:pPr algn="l" indent="0" marL="0">
-                        <a:buNone/>
-                      </a:pPr>
-                      <a:r>
-                        <a:rPr lang="en-US" sz="1100" dirty="0">
-                          <a:solidFill>
-                            <a:srgbClr val="16222E"/>
-                          </a:solidFill>
-                          <a:latin typeface="Calibri" pitchFamily="34" charset="0"/>
-                          <a:ea typeface="Calibri" pitchFamily="34" charset="-122"/>
-                          <a:cs typeface="Calibri" pitchFamily="34" charset="-120"/>
-                        </a:rPr>
-                        <a:t>Activation (bonus)</a:t>
-                      </a:r>
-                      <a:endParaRPr lang="en-US" sz="1100" dirty="0">
-                        <a:latin typeface="Calibri" charset="0"/>
-                        <a:ea typeface="Calibri" charset="0"/>
-                        <a:cs typeface="Calibri" charset="0"/>
-                      </a:endParaRPr>
-                    </a:p>
-                  </a:txBody>
-                  <a:tcPr marL="91440" marR="91440" marT="45720" marB="45720" anchor="ctr">
-                    <a:lnL w="7620" cap="flat" cmpd="sng" algn="ctr">
-                      <a:solidFill>
-                        <a:srgbClr val="DCE5EC"/>
-                      </a:solidFill>
-                      <a:prstDash val="solid"/>
-                      <a:round/>
-                      <a:headEnd type="none" w="med" len="med"/>
-                      <a:tailEnd type="none" w="med" len="med"/>
-                    </a:lnL>
-                    <a:lnR w="7620" cap="flat" cmpd="sng" algn="ctr">
-                      <a:solidFill>
-                        <a:srgbClr val="DCE5EC"/>
-                      </a:solidFill>
-                      <a:prstDash val="solid"/>
-                      <a:round/>
-                      <a:headEnd type="none" w="med" len="med"/>
-                      <a:tailEnd type="none" w="med" len="med"/>
-                    </a:lnR>
-                    <a:lnT w="7620" cap="flat" cmpd="sng" algn="ctr">
-                      <a:solidFill>
-                        <a:srgbClr val="DCE5EC"/>
-                      </a:solidFill>
-                      <a:prstDash val="solid"/>
-                      <a:round/>
-                      <a:headEnd type="none" w="med" len="med"/>
-                      <a:tailEnd type="none" w="med" len="med"/>
-                    </a:lnT>
-                    <a:lnB w="7620" cap="flat" cmpd="sng" algn="ctr">
-                      <a:solidFill>
-                        <a:srgbClr val="DCE5EC"/>
-                      </a:solidFill>
-                      <a:prstDash val="solid"/>
-                      <a:round/>
-                      <a:headEnd type="none" w="med" len="med"/>
-                      <a:tailEnd type="none" w="med" len="med"/>
-                    </a:lnB>
-                    <a:solidFill>
-                      <a:srgbClr val="FFFFFF"/>
-                    </a:solidFill>
-                  </a:tcPr>
-                </a:tc>
-                <a:tc>
-                  <a:txBody>
-                    <a:bodyPr/>
-                    <a:lstStyle/>
-                    <a:p>
-                      <a:pPr algn="l" indent="0" marL="0">
-                        <a:buNone/>
-                      </a:pPr>
-                      <a:r>
-                        <a:rPr lang="en-US" sz="1100" dirty="0">
-                          <a:solidFill>
-                            <a:srgbClr val="16222E"/>
-                          </a:solidFill>
-                          <a:latin typeface="Calibri" pitchFamily="34" charset="0"/>
-                          <a:ea typeface="Calibri" pitchFamily="34" charset="-122"/>
-                          <a:cs typeface="Calibri" pitchFamily="34" charset="-120"/>
-                        </a:rPr>
-                        <a:t>Optional ReLU</a:t>
-                      </a:r>
-                      <a:endParaRPr lang="en-US" sz="1100" dirty="0">
-                        <a:latin typeface="Calibri" charset="0"/>
-                        <a:ea typeface="Calibri" charset="0"/>
-                        <a:cs typeface="Calibri" charset="0"/>
-                      </a:endParaRPr>
-                    </a:p>
-                  </a:txBody>
-                  <a:tcPr marL="91440" marR="91440" marT="45720" marB="45720" anchor="ctr">
-                    <a:lnL w="7620" cap="flat" cmpd="sng" algn="ctr">
-                      <a:solidFill>
-                        <a:srgbClr val="DCE5EC"/>
-                      </a:solidFill>
-                      <a:prstDash val="solid"/>
-                      <a:round/>
-                      <a:headEnd type="none" w="med" len="med"/>
-                      <a:tailEnd type="none" w="med" len="med"/>
-                    </a:lnL>
-                    <a:lnR w="7620" cap="flat" cmpd="sng" algn="ctr">
-                      <a:solidFill>
-                        <a:srgbClr val="DCE5EC"/>
-                      </a:solidFill>
-                      <a:prstDash val="solid"/>
-                      <a:round/>
-                      <a:headEnd type="none" w="med" len="med"/>
-                      <a:tailEnd type="none" w="med" len="med"/>
-                    </a:lnR>
-                    <a:lnT w="7620" cap="flat" cmpd="sng" algn="ctr">
-                      <a:solidFill>
-                        <a:srgbClr val="DCE5EC"/>
-                      </a:solidFill>
-                      <a:prstDash val="solid"/>
-                      <a:round/>
-                      <a:headEnd type="none" w="med" len="med"/>
-                      <a:tailEnd type="none" w="med" len="med"/>
-                    </a:lnT>
-                    <a:lnB w="7620" cap="flat" cmpd="sng" algn="ctr">
-                      <a:solidFill>
-                        <a:srgbClr val="DCE5EC"/>
-                      </a:solidFill>
-                      <a:prstDash val="solid"/>
-                      <a:round/>
-                      <a:headEnd type="none" w="med" len="med"/>
-                      <a:tailEnd type="none" w="med" len="med"/>
-                    </a:lnB>
-                    <a:solidFill>
-                      <a:srgbClr val="FFFFFF"/>
-                    </a:solidFill>
-                  </a:tcPr>
-                </a:tc>
-                <a:tc>
-                  <a:txBody>
-                    <a:bodyPr/>
-                    <a:lstStyle/>
-                    <a:p>
-                      <a:pPr algn="l" indent="0" marL="0">
-                        <a:buNone/>
-                      </a:pPr>
-                      <a:r>
-                        <a:rPr lang="en-US" sz="1100" dirty="0">
-                          <a:solidFill>
-                            <a:srgbClr val="16222E"/>
-                          </a:solidFill>
-                          <a:latin typeface="Calibri" pitchFamily="34" charset="0"/>
-                          <a:ea typeface="Calibri" pitchFamily="34" charset="-122"/>
-                          <a:cs typeface="Calibri" pitchFamily="34" charset="-120"/>
-                        </a:rPr>
-                        <a:t>Implemented</a:t>
+                        <a:t>+ column masking, output FIFO</a:t>
                       </a:r>
                       <a:endParaRPr lang="en-US" sz="1100" dirty="0">
                         <a:latin typeface="Calibri" charset="0"/>
@@ -4561,7 +4370,143 @@
                           <a:ea typeface="Calibri" pitchFamily="34" charset="-122"/>
                           <a:cs typeface="Calibri" pitchFamily="34" charset="-120"/>
                         </a:rPr>
-                        <a:t>Architecture type</a:t>
+                        <a:t>Multipliers</a:t>
+                      </a:r>
+                      <a:endParaRPr lang="en-US" sz="1100" dirty="0">
+                        <a:latin typeface="Calibri" charset="0"/>
+                        <a:ea typeface="Calibri" charset="0"/>
+                        <a:cs typeface="Calibri" charset="0"/>
+                      </a:endParaRPr>
+                    </a:p>
+                  </a:txBody>
+                  <a:tcPr marL="91440" marR="91440" marT="45720" marB="45720" anchor="ctr">
+                    <a:lnL w="7620" cap="flat" cmpd="sng" algn="ctr">
+                      <a:solidFill>
+                        <a:srgbClr val="DCE5EC"/>
+                      </a:solidFill>
+                      <a:prstDash val="solid"/>
+                      <a:round/>
+                      <a:headEnd type="none" w="med" len="med"/>
+                      <a:tailEnd type="none" w="med" len="med"/>
+                    </a:lnL>
+                    <a:lnR w="7620" cap="flat" cmpd="sng" algn="ctr">
+                      <a:solidFill>
+                        <a:srgbClr val="DCE5EC"/>
+                      </a:solidFill>
+                      <a:prstDash val="solid"/>
+                      <a:round/>
+                      <a:headEnd type="none" w="med" len="med"/>
+                      <a:tailEnd type="none" w="med" len="med"/>
+                    </a:lnR>
+                    <a:lnT w="7620" cap="flat" cmpd="sng" algn="ctr">
+                      <a:solidFill>
+                        <a:srgbClr val="DCE5EC"/>
+                      </a:solidFill>
+                      <a:prstDash val="solid"/>
+                      <a:round/>
+                      <a:headEnd type="none" w="med" len="med"/>
+                      <a:tailEnd type="none" w="med" len="med"/>
+                    </a:lnT>
+                    <a:lnB w="7620" cap="flat" cmpd="sng" algn="ctr">
+                      <a:solidFill>
+                        <a:srgbClr val="DCE5EC"/>
+                      </a:solidFill>
+                      <a:prstDash val="solid"/>
+                      <a:round/>
+                      <a:headEnd type="none" w="med" len="med"/>
+                      <a:tailEnd type="none" w="med" len="med"/>
+                    </a:lnB>
+                    <a:solidFill>
+                      <a:srgbClr val="FFFFFF"/>
+                    </a:solidFill>
+                  </a:tcPr>
+                </a:tc>
+                <a:tc>
+                  <a:txBody>
+                    <a:bodyPr/>
+                    <a:lstStyle/>
+                    <a:p>
+                      <a:pPr algn="l" indent="0" marL="0">
+                        <a:buNone/>
+                      </a:pPr>
+                      <a:r>
+                        <a:rPr lang="en-US" sz="1100" dirty="0">
+                          <a:solidFill>
+                            <a:srgbClr val="16222E"/>
+                          </a:solidFill>
+                          <a:latin typeface="Calibri" pitchFamily="34" charset="0"/>
+                          <a:ea typeface="Calibri" pitchFamily="34" charset="-122"/>
+                          <a:cs typeface="Calibri" pitchFamily="34" charset="-120"/>
+                        </a:rPr>
+                        <a:t>9 (DSP48E)</a:t>
+                      </a:r>
+                      <a:endParaRPr lang="en-US" sz="1100" dirty="0">
+                        <a:latin typeface="Calibri" charset="0"/>
+                        <a:ea typeface="Calibri" charset="0"/>
+                        <a:cs typeface="Calibri" charset="0"/>
+                      </a:endParaRPr>
+                    </a:p>
+                  </a:txBody>
+                  <a:tcPr marL="91440" marR="91440" marT="45720" marB="45720" anchor="ctr">
+                    <a:lnL w="7620" cap="flat" cmpd="sng" algn="ctr">
+                      <a:solidFill>
+                        <a:srgbClr val="DCE5EC"/>
+                      </a:solidFill>
+                      <a:prstDash val="solid"/>
+                      <a:round/>
+                      <a:headEnd type="none" w="med" len="med"/>
+                      <a:tailEnd type="none" w="med" len="med"/>
+                    </a:lnL>
+                    <a:lnR w="7620" cap="flat" cmpd="sng" algn="ctr">
+                      <a:solidFill>
+                        <a:srgbClr val="DCE5EC"/>
+                      </a:solidFill>
+                      <a:prstDash val="solid"/>
+                      <a:round/>
+                      <a:headEnd type="none" w="med" len="med"/>
+                      <a:tailEnd type="none" w="med" len="med"/>
+                    </a:lnR>
+                    <a:lnT w="7620" cap="flat" cmpd="sng" algn="ctr">
+                      <a:solidFill>
+                        <a:srgbClr val="DCE5EC"/>
+                      </a:solidFill>
+                      <a:prstDash val="solid"/>
+                      <a:round/>
+                      <a:headEnd type="none" w="med" len="med"/>
+                      <a:tailEnd type="none" w="med" len="med"/>
+                    </a:lnT>
+                    <a:lnB w="7620" cap="flat" cmpd="sng" algn="ctr">
+                      <a:solidFill>
+                        <a:srgbClr val="DCE5EC"/>
+                      </a:solidFill>
+                      <a:prstDash val="solid"/>
+                      <a:round/>
+                      <a:headEnd type="none" w="med" len="med"/>
+                      <a:tailEnd type="none" w="med" len="med"/>
+                    </a:lnB>
+                    <a:solidFill>
+                      <a:srgbClr val="FFFFFF"/>
+                    </a:solidFill>
+                  </a:tcPr>
+                </a:tc>
+                <a:tc>
+                  <a:txBody>
+                    <a:bodyPr/>
+                    <a:lstStyle/>
+                    <a:p>
+                      <a:pPr algn="l" indent="0" marL="0">
+                        <a:buNone/>
+                      </a:pPr>
+                      <a:r>
+                        <a:rPr lang="en-US" sz="1100" dirty="0">
+                          <a:solidFill>
+                            <a:srgbClr val="16222E"/>
+                          </a:solidFill>
+                          <a:latin typeface="Calibri" pitchFamily="34" charset="0"/>
+                          <a:ea typeface="Calibri" pitchFamily="34" charset="-122"/>
+                          <a:cs typeface="Calibri" pitchFamily="34" charset="-120"/>
+                        </a:rPr>
+                        <a:t>9 (DSP48E)</a:t>
                       </a:r>
                       <a:endParaRPr lang="en-US" sz="1100" dirty="0">
                         <a:latin typeface="Calibri" charset="0"/>
@@ -4680,6 +4625,8 @@
                     </a:solidFill>
                   </a:tcPr>
                 </a:tc>
+              </a:tr>
+              <a:tr h="265176">
                 <a:tc>
                   <a:txBody>
                     <a:bodyPr/>
@@ -4697,7 +4644,7 @@
                           <a:ea typeface="Calibri" pitchFamily="34" charset="-122"/>
                           <a:cs typeface="Calibri" pitchFamily="34" charset="-120"/>
                         </a:rPr>
-                        <a:t>Line-buffer sliding window</a:t>
+                        <a:t>Latency, first output</a:t>
                       </a:r>
                       <a:endParaRPr lang="en-US" sz="1100" dirty="0">
                         <a:latin typeface="Calibri" charset="0"/>
@@ -4765,77 +4712,7 @@
                           <a:ea typeface="Calibri" pitchFamily="34" charset="-122"/>
                           <a:cs typeface="Calibri" pitchFamily="34" charset="-120"/>
                         </a:rPr>
-                        <a:t>—</a:t>
-                      </a:r>
-                      <a:endParaRPr lang="en-US" sz="1100" dirty="0">
-                        <a:latin typeface="Calibri" charset="0"/>
-                        <a:ea typeface="Calibri" charset="0"/>
-                        <a:cs typeface="Calibri" charset="0"/>
-                      </a:endParaRPr>
-                    </a:p>
-                  </a:txBody>
-                  <a:tcPr marL="91440" marR="91440" marT="45720" marB="45720" anchor="ctr">
-                    <a:lnL w="7620" cap="flat" cmpd="sng" algn="ctr">
-                      <a:solidFill>
-                        <a:srgbClr val="DCE5EC"/>
-                      </a:solidFill>
-                      <a:prstDash val="solid"/>
-                      <a:round/>
-                      <a:headEnd type="none" w="med" len="med"/>
-                      <a:tailEnd type="none" w="med" len="med"/>
-                    </a:lnL>
-                    <a:lnR w="7620" cap="flat" cmpd="sng" algn="ctr">
-                      <a:solidFill>
-                        <a:srgbClr val="DCE5EC"/>
-                      </a:solidFill>
-                      <a:prstDash val="solid"/>
-                      <a:round/>
-                      <a:headEnd type="none" w="med" len="med"/>
-                      <a:tailEnd type="none" w="med" len="med"/>
-                    </a:lnR>
-                    <a:lnT w="7620" cap="flat" cmpd="sng" algn="ctr">
-                      <a:solidFill>
-                        <a:srgbClr val="DCE5EC"/>
-                      </a:solidFill>
-                      <a:prstDash val="solid"/>
-                      <a:round/>
-                      <a:headEnd type="none" w="med" len="med"/>
-                      <a:tailEnd type="none" w="med" len="med"/>
-                    </a:lnT>
-                    <a:lnB w="7620" cap="flat" cmpd="sng" algn="ctr">
-                      <a:solidFill>
-                        <a:srgbClr val="DCE5EC"/>
-                      </a:solidFill>
-                      <a:prstDash val="solid"/>
-                      <a:round/>
-                      <a:headEnd type="none" w="med" len="med"/>
-                      <a:tailEnd type="none" w="med" len="med"/>
-                    </a:lnB>
-                    <a:solidFill>
-                      <a:srgbClr val="FFFFFF"/>
-                    </a:solidFill>
-                  </a:tcPr>
-                </a:tc>
-              </a:tr>
-              <a:tr h="265176">
-                <a:tc>
-                  <a:txBody>
-                    <a:bodyPr/>
-                    <a:lstStyle/>
-                    <a:p>
-                      <a:pPr algn="l" indent="0" marL="0">
-                        <a:buNone/>
-                      </a:pPr>
-                      <a:r>
-                        <a:rPr lang="en-US" sz="1100" dirty="0">
-                          <a:solidFill>
-                            <a:srgbClr val="16222E"/>
-                          </a:solidFill>
-                          <a:latin typeface="Calibri" pitchFamily="34" charset="0"/>
-                          <a:ea typeface="Calibri" pitchFamily="34" charset="-122"/>
-                          <a:cs typeface="Calibri" pitchFamily="34" charset="-120"/>
-                        </a:rPr>
-                        <a:t>Multipliers / MACs</a:t>
+                        <a:t>70</a:t>
                       </a:r>
                       <a:endParaRPr lang="en-US" sz="1100" dirty="0">
                         <a:latin typeface="Calibri" charset="0"/>
@@ -4903,623 +4780,7 @@
                           <a:ea typeface="Calibri" pitchFamily="34" charset="-122"/>
                           <a:cs typeface="Calibri" pitchFamily="34" charset="-120"/>
                         </a:rPr>
-                        <a:t>—</a:t>
-                      </a:r>
-                      <a:endParaRPr lang="en-US" sz="1100" dirty="0">
-                        <a:latin typeface="Calibri" charset="0"/>
-                        <a:ea typeface="Calibri" charset="0"/>
-                        <a:cs typeface="Calibri" charset="0"/>
-                      </a:endParaRPr>
-                    </a:p>
-                  </a:txBody>
-                  <a:tcPr marL="91440" marR="91440" marT="45720" marB="45720" anchor="ctr">
-                    <a:lnL w="7620" cap="flat" cmpd="sng" algn="ctr">
-                      <a:solidFill>
-                        <a:srgbClr val="DCE5EC"/>
-                      </a:solidFill>
-                      <a:prstDash val="solid"/>
-                      <a:round/>
-                      <a:headEnd type="none" w="med" len="med"/>
-                      <a:tailEnd type="none" w="med" len="med"/>
-                    </a:lnL>
-                    <a:lnR w="7620" cap="flat" cmpd="sng" algn="ctr">
-                      <a:solidFill>
-                        <a:srgbClr val="DCE5EC"/>
-                      </a:solidFill>
-                      <a:prstDash val="solid"/>
-                      <a:round/>
-                      <a:headEnd type="none" w="med" len="med"/>
-                      <a:tailEnd type="none" w="med" len="med"/>
-                    </a:lnR>
-                    <a:lnT w="7620" cap="flat" cmpd="sng" algn="ctr">
-                      <a:solidFill>
-                        <a:srgbClr val="DCE5EC"/>
-                      </a:solidFill>
-                      <a:prstDash val="solid"/>
-                      <a:round/>
-                      <a:headEnd type="none" w="med" len="med"/>
-                      <a:tailEnd type="none" w="med" len="med"/>
-                    </a:lnT>
-                    <a:lnB w="7620" cap="flat" cmpd="sng" algn="ctr">
-                      <a:solidFill>
-                        <a:srgbClr val="DCE5EC"/>
-                      </a:solidFill>
-                      <a:prstDash val="solid"/>
-                      <a:round/>
-                      <a:headEnd type="none" w="med" len="med"/>
-                      <a:tailEnd type="none" w="med" len="med"/>
-                    </a:lnB>
-                    <a:solidFill>
-                      <a:srgbClr val="FFFFFF"/>
-                    </a:solidFill>
-                  </a:tcPr>
-                </a:tc>
-                <a:tc>
-                  <a:txBody>
-                    <a:bodyPr/>
-                    <a:lstStyle/>
-                    <a:p>
-                      <a:pPr algn="l" indent="0" marL="0">
-                        <a:buNone/>
-                      </a:pPr>
-                      <a:r>
-                        <a:rPr lang="en-US" sz="1100" dirty="0">
-                          <a:solidFill>
-                            <a:srgbClr val="16222E"/>
-                          </a:solidFill>
-                          <a:latin typeface="Calibri" pitchFamily="34" charset="0"/>
-                          <a:ea typeface="Calibri" pitchFamily="34" charset="-122"/>
-                          <a:cs typeface="Calibri" pitchFamily="34" charset="-120"/>
-                        </a:rPr>
-                        <a:t>9 (DSP48E)</a:t>
-                      </a:r>
-                      <a:endParaRPr lang="en-US" sz="1100" dirty="0">
-                        <a:latin typeface="Calibri" charset="0"/>
-                        <a:ea typeface="Calibri" charset="0"/>
-                        <a:cs typeface="Calibri" charset="0"/>
-                      </a:endParaRPr>
-                    </a:p>
-                  </a:txBody>
-                  <a:tcPr marL="91440" marR="91440" marT="45720" marB="45720" anchor="ctr">
-                    <a:lnL w="7620" cap="flat" cmpd="sng" algn="ctr">
-                      <a:solidFill>
-                        <a:srgbClr val="DCE5EC"/>
-                      </a:solidFill>
-                      <a:prstDash val="solid"/>
-                      <a:round/>
-                      <a:headEnd type="none" w="med" len="med"/>
-                      <a:tailEnd type="none" w="med" len="med"/>
-                    </a:lnL>
-                    <a:lnR w="7620" cap="flat" cmpd="sng" algn="ctr">
-                      <a:solidFill>
-                        <a:srgbClr val="DCE5EC"/>
-                      </a:solidFill>
-                      <a:prstDash val="solid"/>
-                      <a:round/>
-                      <a:headEnd type="none" w="med" len="med"/>
-                      <a:tailEnd type="none" w="med" len="med"/>
-                    </a:lnR>
-                    <a:lnT w="7620" cap="flat" cmpd="sng" algn="ctr">
-                      <a:solidFill>
-                        <a:srgbClr val="DCE5EC"/>
-                      </a:solidFill>
-                      <a:prstDash val="solid"/>
-                      <a:round/>
-                      <a:headEnd type="none" w="med" len="med"/>
-                      <a:tailEnd type="none" w="med" len="med"/>
-                    </a:lnT>
-                    <a:lnB w="7620" cap="flat" cmpd="sng" algn="ctr">
-                      <a:solidFill>
-                        <a:srgbClr val="DCE5EC"/>
-                      </a:solidFill>
-                      <a:prstDash val="solid"/>
-                      <a:round/>
-                      <a:headEnd type="none" w="med" len="med"/>
-                      <a:tailEnd type="none" w="med" len="med"/>
-                    </a:lnB>
-                    <a:solidFill>
-                      <a:srgbClr val="FFFFFF"/>
-                    </a:solidFill>
-                  </a:tcPr>
-                </a:tc>
-                <a:tc>
-                  <a:txBody>
-                    <a:bodyPr/>
-                    <a:lstStyle/>
-                    <a:p>
-                      <a:pPr algn="l" indent="0" marL="0">
-                        <a:buNone/>
-                      </a:pPr>
-                      <a:r>
-                        <a:rPr lang="en-US" sz="1100" dirty="0">
-                          <a:solidFill>
-                            <a:srgbClr val="16222E"/>
-                          </a:solidFill>
-                          <a:latin typeface="Calibri" pitchFamily="34" charset="0"/>
-                          <a:ea typeface="Calibri" pitchFamily="34" charset="-122"/>
-                          <a:cs typeface="Calibri" pitchFamily="34" charset="-120"/>
-                        </a:rPr>
-                        <a:t>—</a:t>
-                      </a:r>
-                      <a:endParaRPr lang="en-US" sz="1100" dirty="0">
-                        <a:latin typeface="Calibri" charset="0"/>
-                        <a:ea typeface="Calibri" charset="0"/>
-                        <a:cs typeface="Calibri" charset="0"/>
-                      </a:endParaRPr>
-                    </a:p>
-                  </a:txBody>
-                  <a:tcPr marL="91440" marR="91440" marT="45720" marB="45720" anchor="ctr">
-                    <a:lnL w="7620" cap="flat" cmpd="sng" algn="ctr">
-                      <a:solidFill>
-                        <a:srgbClr val="DCE5EC"/>
-                      </a:solidFill>
-                      <a:prstDash val="solid"/>
-                      <a:round/>
-                      <a:headEnd type="none" w="med" len="med"/>
-                      <a:tailEnd type="none" w="med" len="med"/>
-                    </a:lnL>
-                    <a:lnR w="7620" cap="flat" cmpd="sng" algn="ctr">
-                      <a:solidFill>
-                        <a:srgbClr val="DCE5EC"/>
-                      </a:solidFill>
-                      <a:prstDash val="solid"/>
-                      <a:round/>
-                      <a:headEnd type="none" w="med" len="med"/>
-                      <a:tailEnd type="none" w="med" len="med"/>
-                    </a:lnR>
-                    <a:lnT w="7620" cap="flat" cmpd="sng" algn="ctr">
-                      <a:solidFill>
-                        <a:srgbClr val="DCE5EC"/>
-                      </a:solidFill>
-                      <a:prstDash val="solid"/>
-                      <a:round/>
-                      <a:headEnd type="none" w="med" len="med"/>
-                      <a:tailEnd type="none" w="med" len="med"/>
-                    </a:lnT>
-                    <a:lnB w="7620" cap="flat" cmpd="sng" algn="ctr">
-                      <a:solidFill>
-                        <a:srgbClr val="DCE5EC"/>
-                      </a:solidFill>
-                      <a:prstDash val="solid"/>
-                      <a:round/>
-                      <a:headEnd type="none" w="med" len="med"/>
-                      <a:tailEnd type="none" w="med" len="med"/>
-                    </a:lnB>
-                    <a:solidFill>
-                      <a:srgbClr val="FFFFFF"/>
-                    </a:solidFill>
-                  </a:tcPr>
-                </a:tc>
-              </a:tr>
-              <a:tr h="265176">
-                <a:tc>
-                  <a:txBody>
-                    <a:bodyPr/>
-                    <a:lstStyle/>
-                    <a:p>
-                      <a:pPr algn="l" indent="0" marL="0">
-                        <a:buNone/>
-                      </a:pPr>
-                      <a:r>
-                        <a:rPr lang="en-US" sz="1100" dirty="0">
-                          <a:solidFill>
-                            <a:srgbClr val="16222E"/>
-                          </a:solidFill>
-                          <a:latin typeface="Calibri" pitchFamily="34" charset="0"/>
-                          <a:ea typeface="Calibri" pitchFamily="34" charset="-122"/>
-                          <a:cs typeface="Calibri" pitchFamily="34" charset="-120"/>
-                        </a:rPr>
-                        <a:t>Pipeline stages</a:t>
-                      </a:r>
-                      <a:endParaRPr lang="en-US" sz="1100" dirty="0">
-                        <a:latin typeface="Calibri" charset="0"/>
-                        <a:ea typeface="Calibri" charset="0"/>
-                        <a:cs typeface="Calibri" charset="0"/>
-                      </a:endParaRPr>
-                    </a:p>
-                  </a:txBody>
-                  <a:tcPr marL="91440" marR="91440" marT="45720" marB="45720" anchor="ctr">
-                    <a:lnL w="7620" cap="flat" cmpd="sng" algn="ctr">
-                      <a:solidFill>
-                        <a:srgbClr val="DCE5EC"/>
-                      </a:solidFill>
-                      <a:prstDash val="solid"/>
-                      <a:round/>
-                      <a:headEnd type="none" w="med" len="med"/>
-                      <a:tailEnd type="none" w="med" len="med"/>
-                    </a:lnL>
-                    <a:lnR w="7620" cap="flat" cmpd="sng" algn="ctr">
-                      <a:solidFill>
-                        <a:srgbClr val="DCE5EC"/>
-                      </a:solidFill>
-                      <a:prstDash val="solid"/>
-                      <a:round/>
-                      <a:headEnd type="none" w="med" len="med"/>
-                      <a:tailEnd type="none" w="med" len="med"/>
-                    </a:lnR>
-                    <a:lnT w="7620" cap="flat" cmpd="sng" algn="ctr">
-                      <a:solidFill>
-                        <a:srgbClr val="DCE5EC"/>
-                      </a:solidFill>
-                      <a:prstDash val="solid"/>
-                      <a:round/>
-                      <a:headEnd type="none" w="med" len="med"/>
-                      <a:tailEnd type="none" w="med" len="med"/>
-                    </a:lnT>
-                    <a:lnB w="7620" cap="flat" cmpd="sng" algn="ctr">
-                      <a:solidFill>
-                        <a:srgbClr val="DCE5EC"/>
-                      </a:solidFill>
-                      <a:prstDash val="solid"/>
-                      <a:round/>
-                      <a:headEnd type="none" w="med" len="med"/>
-                      <a:tailEnd type="none" w="med" len="med"/>
-                    </a:lnB>
-                    <a:solidFill>
-                      <a:srgbClr val="FFFFFF"/>
-                    </a:solidFill>
-                  </a:tcPr>
-                </a:tc>
-                <a:tc>
-                  <a:txBody>
-                    <a:bodyPr/>
-                    <a:lstStyle/>
-                    <a:p>
-                      <a:pPr algn="l" indent="0" marL="0">
-                        <a:buNone/>
-                      </a:pPr>
-                      <a:r>
-                        <a:rPr lang="en-US" sz="1100" dirty="0">
-                          <a:solidFill>
-                            <a:srgbClr val="16222E"/>
-                          </a:solidFill>
-                          <a:latin typeface="Calibri" pitchFamily="34" charset="0"/>
-                          <a:ea typeface="Calibri" pitchFamily="34" charset="-122"/>
-                          <a:cs typeface="Calibri" pitchFamily="34" charset="-120"/>
-                        </a:rPr>
-                        <a:t>—</a:t>
-                      </a:r>
-                      <a:endParaRPr lang="en-US" sz="1100" dirty="0">
-                        <a:latin typeface="Calibri" charset="0"/>
-                        <a:ea typeface="Calibri" charset="0"/>
-                        <a:cs typeface="Calibri" charset="0"/>
-                      </a:endParaRPr>
-                    </a:p>
-                  </a:txBody>
-                  <a:tcPr marL="91440" marR="91440" marT="45720" marB="45720" anchor="ctr">
-                    <a:lnL w="7620" cap="flat" cmpd="sng" algn="ctr">
-                      <a:solidFill>
-                        <a:srgbClr val="DCE5EC"/>
-                      </a:solidFill>
-                      <a:prstDash val="solid"/>
-                      <a:round/>
-                      <a:headEnd type="none" w="med" len="med"/>
-                      <a:tailEnd type="none" w="med" len="med"/>
-                    </a:lnL>
-                    <a:lnR w="7620" cap="flat" cmpd="sng" algn="ctr">
-                      <a:solidFill>
-                        <a:srgbClr val="DCE5EC"/>
-                      </a:solidFill>
-                      <a:prstDash val="solid"/>
-                      <a:round/>
-                      <a:headEnd type="none" w="med" len="med"/>
-                      <a:tailEnd type="none" w="med" len="med"/>
-                    </a:lnR>
-                    <a:lnT w="7620" cap="flat" cmpd="sng" algn="ctr">
-                      <a:solidFill>
-                        <a:srgbClr val="DCE5EC"/>
-                      </a:solidFill>
-                      <a:prstDash val="solid"/>
-                      <a:round/>
-                      <a:headEnd type="none" w="med" len="med"/>
-                      <a:tailEnd type="none" w="med" len="med"/>
-                    </a:lnT>
-                    <a:lnB w="7620" cap="flat" cmpd="sng" algn="ctr">
-                      <a:solidFill>
-                        <a:srgbClr val="DCE5EC"/>
-                      </a:solidFill>
-                      <a:prstDash val="solid"/>
-                      <a:round/>
-                      <a:headEnd type="none" w="med" len="med"/>
-                      <a:tailEnd type="none" w="med" len="med"/>
-                    </a:lnB>
-                    <a:solidFill>
-                      <a:srgbClr val="FFFFFF"/>
-                    </a:solidFill>
-                  </a:tcPr>
-                </a:tc>
-                <a:tc>
-                  <a:txBody>
-                    <a:bodyPr/>
-                    <a:lstStyle/>
-                    <a:p>
-                      <a:pPr algn="l" indent="0" marL="0">
-                        <a:buNone/>
-                      </a:pPr>
-                      <a:r>
-                        <a:rPr lang="en-US" sz="1100" dirty="0">
-                          <a:solidFill>
-                            <a:srgbClr val="16222E"/>
-                          </a:solidFill>
-                          <a:latin typeface="Calibri" pitchFamily="34" charset="0"/>
-                          <a:ea typeface="Calibri" pitchFamily="34" charset="-122"/>
-                          <a:cs typeface="Calibri" pitchFamily="34" charset="-120"/>
-                        </a:rPr>
-                        <a:t>3 + window</a:t>
-                      </a:r>
-                      <a:endParaRPr lang="en-US" sz="1100" dirty="0">
-                        <a:latin typeface="Calibri" charset="0"/>
-                        <a:ea typeface="Calibri" charset="0"/>
-                        <a:cs typeface="Calibri" charset="0"/>
-                      </a:endParaRPr>
-                    </a:p>
-                  </a:txBody>
-                  <a:tcPr marL="91440" marR="91440" marT="45720" marB="45720" anchor="ctr">
-                    <a:lnL w="7620" cap="flat" cmpd="sng" algn="ctr">
-                      <a:solidFill>
-                        <a:srgbClr val="DCE5EC"/>
-                      </a:solidFill>
-                      <a:prstDash val="solid"/>
-                      <a:round/>
-                      <a:headEnd type="none" w="med" len="med"/>
-                      <a:tailEnd type="none" w="med" len="med"/>
-                    </a:lnL>
-                    <a:lnR w="7620" cap="flat" cmpd="sng" algn="ctr">
-                      <a:solidFill>
-                        <a:srgbClr val="DCE5EC"/>
-                      </a:solidFill>
-                      <a:prstDash val="solid"/>
-                      <a:round/>
-                      <a:headEnd type="none" w="med" len="med"/>
-                      <a:tailEnd type="none" w="med" len="med"/>
-                    </a:lnR>
-                    <a:lnT w="7620" cap="flat" cmpd="sng" algn="ctr">
-                      <a:solidFill>
-                        <a:srgbClr val="DCE5EC"/>
-                      </a:solidFill>
-                      <a:prstDash val="solid"/>
-                      <a:round/>
-                      <a:headEnd type="none" w="med" len="med"/>
-                      <a:tailEnd type="none" w="med" len="med"/>
-                    </a:lnT>
-                    <a:lnB w="7620" cap="flat" cmpd="sng" algn="ctr">
-                      <a:solidFill>
-                        <a:srgbClr val="DCE5EC"/>
-                      </a:solidFill>
-                      <a:prstDash val="solid"/>
-                      <a:round/>
-                      <a:headEnd type="none" w="med" len="med"/>
-                      <a:tailEnd type="none" w="med" len="med"/>
-                    </a:lnB>
-                    <a:solidFill>
-                      <a:srgbClr val="FFFFFF"/>
-                    </a:solidFill>
-                  </a:tcPr>
-                </a:tc>
-                <a:tc>
-                  <a:txBody>
-                    <a:bodyPr/>
-                    <a:lstStyle/>
-                    <a:p>
-                      <a:pPr algn="l" indent="0" marL="0">
-                        <a:buNone/>
-                      </a:pPr>
-                      <a:r>
-                        <a:rPr lang="en-US" sz="1100" dirty="0">
-                          <a:solidFill>
-                            <a:srgbClr val="16222E"/>
-                          </a:solidFill>
-                          <a:latin typeface="Calibri" pitchFamily="34" charset="0"/>
-                          <a:ea typeface="Calibri" pitchFamily="34" charset="-122"/>
-                          <a:cs typeface="Calibri" pitchFamily="34" charset="-120"/>
-                        </a:rPr>
-                        <a:t>—</a:t>
-                      </a:r>
-                      <a:endParaRPr lang="en-US" sz="1100" dirty="0">
-                        <a:latin typeface="Calibri" charset="0"/>
-                        <a:ea typeface="Calibri" charset="0"/>
-                        <a:cs typeface="Calibri" charset="0"/>
-                      </a:endParaRPr>
-                    </a:p>
-                  </a:txBody>
-                  <a:tcPr marL="91440" marR="91440" marT="45720" marB="45720" anchor="ctr">
-                    <a:lnL w="7620" cap="flat" cmpd="sng" algn="ctr">
-                      <a:solidFill>
-                        <a:srgbClr val="DCE5EC"/>
-                      </a:solidFill>
-                      <a:prstDash val="solid"/>
-                      <a:round/>
-                      <a:headEnd type="none" w="med" len="med"/>
-                      <a:tailEnd type="none" w="med" len="med"/>
-                    </a:lnL>
-                    <a:lnR w="7620" cap="flat" cmpd="sng" algn="ctr">
-                      <a:solidFill>
-                        <a:srgbClr val="DCE5EC"/>
-                      </a:solidFill>
-                      <a:prstDash val="solid"/>
-                      <a:round/>
-                      <a:headEnd type="none" w="med" len="med"/>
-                      <a:tailEnd type="none" w="med" len="med"/>
-                    </a:lnR>
-                    <a:lnT w="7620" cap="flat" cmpd="sng" algn="ctr">
-                      <a:solidFill>
-                        <a:srgbClr val="DCE5EC"/>
-                      </a:solidFill>
-                      <a:prstDash val="solid"/>
-                      <a:round/>
-                      <a:headEnd type="none" w="med" len="med"/>
-                      <a:tailEnd type="none" w="med" len="med"/>
-                    </a:lnT>
-                    <a:lnB w="7620" cap="flat" cmpd="sng" algn="ctr">
-                      <a:solidFill>
-                        <a:srgbClr val="DCE5EC"/>
-                      </a:solidFill>
-                      <a:prstDash val="solid"/>
-                      <a:round/>
-                      <a:headEnd type="none" w="med" len="med"/>
-                      <a:tailEnd type="none" w="med" len="med"/>
-                    </a:lnB>
-                    <a:solidFill>
-                      <a:srgbClr val="FFFFFF"/>
-                    </a:solidFill>
-                  </a:tcPr>
-                </a:tc>
-              </a:tr>
-              <a:tr h="265176">
-                <a:tc>
-                  <a:txBody>
-                    <a:bodyPr/>
-                    <a:lstStyle/>
-                    <a:p>
-                      <a:pPr algn="l" indent="0" marL="0">
-                        <a:buNone/>
-                      </a:pPr>
-                      <a:r>
-                        <a:rPr lang="en-US" sz="1100" dirty="0">
-                          <a:solidFill>
-                            <a:srgbClr val="16222E"/>
-                          </a:solidFill>
-                          <a:latin typeface="Calibri" pitchFamily="34" charset="0"/>
-                          <a:ea typeface="Calibri" pitchFamily="34" charset="-122"/>
-                          <a:cs typeface="Calibri" pitchFamily="34" charset="-120"/>
-                        </a:rPr>
-                        <a:t>Latency</a:t>
-                      </a:r>
-                      <a:endParaRPr lang="en-US" sz="1100" dirty="0">
-                        <a:latin typeface="Calibri" charset="0"/>
-                        <a:ea typeface="Calibri" charset="0"/>
-                        <a:cs typeface="Calibri" charset="0"/>
-                      </a:endParaRPr>
-                    </a:p>
-                  </a:txBody>
-                  <a:tcPr marL="91440" marR="91440" marT="45720" marB="45720" anchor="ctr">
-                    <a:lnL w="7620" cap="flat" cmpd="sng" algn="ctr">
-                      <a:solidFill>
-                        <a:srgbClr val="DCE5EC"/>
-                      </a:solidFill>
-                      <a:prstDash val="solid"/>
-                      <a:round/>
-                      <a:headEnd type="none" w="med" len="med"/>
-                      <a:tailEnd type="none" w="med" len="med"/>
-                    </a:lnL>
-                    <a:lnR w="7620" cap="flat" cmpd="sng" algn="ctr">
-                      <a:solidFill>
-                        <a:srgbClr val="DCE5EC"/>
-                      </a:solidFill>
-                      <a:prstDash val="solid"/>
-                      <a:round/>
-                      <a:headEnd type="none" w="med" len="med"/>
-                      <a:tailEnd type="none" w="med" len="med"/>
-                    </a:lnR>
-                    <a:lnT w="7620" cap="flat" cmpd="sng" algn="ctr">
-                      <a:solidFill>
-                        <a:srgbClr val="DCE5EC"/>
-                      </a:solidFill>
-                      <a:prstDash val="solid"/>
-                      <a:round/>
-                      <a:headEnd type="none" w="med" len="med"/>
-                      <a:tailEnd type="none" w="med" len="med"/>
-                    </a:lnT>
-                    <a:lnB w="7620" cap="flat" cmpd="sng" algn="ctr">
-                      <a:solidFill>
-                        <a:srgbClr val="DCE5EC"/>
-                      </a:solidFill>
-                      <a:prstDash val="solid"/>
-                      <a:round/>
-                      <a:headEnd type="none" w="med" len="med"/>
-                      <a:tailEnd type="none" w="med" len="med"/>
-                    </a:lnB>
-                    <a:solidFill>
-                      <a:srgbClr val="FFFFFF"/>
-                    </a:solidFill>
-                  </a:tcPr>
-                </a:tc>
-                <a:tc>
-                  <a:txBody>
-                    <a:bodyPr/>
-                    <a:lstStyle/>
-                    <a:p>
-                      <a:pPr algn="l" indent="0" marL="0">
-                        <a:buNone/>
-                      </a:pPr>
-                      <a:r>
-                        <a:rPr lang="en-US" sz="1100" dirty="0">
-                          <a:solidFill>
-                            <a:srgbClr val="16222E"/>
-                          </a:solidFill>
-                          <a:latin typeface="Calibri" pitchFamily="34" charset="0"/>
-                          <a:ea typeface="Calibri" pitchFamily="34" charset="-122"/>
-                          <a:cs typeface="Calibri" pitchFamily="34" charset="-120"/>
-                        </a:rPr>
-                        <a:t>—</a:t>
-                      </a:r>
-                      <a:endParaRPr lang="en-US" sz="1100" dirty="0">
-                        <a:latin typeface="Calibri" charset="0"/>
-                        <a:ea typeface="Calibri" charset="0"/>
-                        <a:cs typeface="Calibri" charset="0"/>
-                      </a:endParaRPr>
-                    </a:p>
-                  </a:txBody>
-                  <a:tcPr marL="91440" marR="91440" marT="45720" marB="45720" anchor="ctr">
-                    <a:lnL w="7620" cap="flat" cmpd="sng" algn="ctr">
-                      <a:solidFill>
-                        <a:srgbClr val="DCE5EC"/>
-                      </a:solidFill>
-                      <a:prstDash val="solid"/>
-                      <a:round/>
-                      <a:headEnd type="none" w="med" len="med"/>
-                      <a:tailEnd type="none" w="med" len="med"/>
-                    </a:lnL>
-                    <a:lnR w="7620" cap="flat" cmpd="sng" algn="ctr">
-                      <a:solidFill>
-                        <a:srgbClr val="DCE5EC"/>
-                      </a:solidFill>
-                      <a:prstDash val="solid"/>
-                      <a:round/>
-                      <a:headEnd type="none" w="med" len="med"/>
-                      <a:tailEnd type="none" w="med" len="med"/>
-                    </a:lnR>
-                    <a:lnT w="7620" cap="flat" cmpd="sng" algn="ctr">
-                      <a:solidFill>
-                        <a:srgbClr val="DCE5EC"/>
-                      </a:solidFill>
-                      <a:prstDash val="solid"/>
-                      <a:round/>
-                      <a:headEnd type="none" w="med" len="med"/>
-                      <a:tailEnd type="none" w="med" len="med"/>
-                    </a:lnT>
-                    <a:lnB w="7620" cap="flat" cmpd="sng" algn="ctr">
-                      <a:solidFill>
-                        <a:srgbClr val="DCE5EC"/>
-                      </a:solidFill>
-                      <a:prstDash val="solid"/>
-                      <a:round/>
-                      <a:headEnd type="none" w="med" len="med"/>
-                      <a:tailEnd type="none" w="med" len="med"/>
-                    </a:lnB>
-                    <a:solidFill>
-                      <a:srgbClr val="FFFFFF"/>
-                    </a:solidFill>
-                  </a:tcPr>
-                </a:tc>
-                <a:tc>
-                  <a:txBody>
-                    <a:bodyPr/>
-                    <a:lstStyle/>
-                    <a:p>
-                      <a:pPr algn="l" indent="0" marL="0">
-                        <a:buNone/>
-                      </a:pPr>
-                      <a:r>
-                        <a:rPr lang="en-US" sz="1100" dirty="0">
-                          <a:solidFill>
-                            <a:srgbClr val="16222E"/>
-                          </a:solidFill>
-                          <a:latin typeface="Calibri" pitchFamily="34" charset="0"/>
-                          <a:ea typeface="Calibri" pitchFamily="34" charset="-122"/>
-                          <a:cs typeface="Calibri" pitchFamily="34" charset="-120"/>
-                        </a:rPr>
-                        <a:t>70 first out; 1,028 per frame</a:t>
+                        <a:t>70</a:t>
                       </a:r>
                       <a:endParaRPr lang="en-US" sz="1100" dirty="0">
                         <a:latin typeface="Calibri" charset="0"/>
@@ -5657,7 +4918,7 @@
                           <a:ea typeface="Calibri" pitchFamily="34" charset="-122"/>
                           <a:cs typeface="Calibri" pitchFamily="34" charset="-120"/>
                         </a:rPr>
-                        <a:t>Throughput</a:t>
+                        <a:t>Frame cycles (32×32)</a:t>
                       </a:r>
                       <a:endParaRPr lang="en-US" sz="1100" dirty="0">
                         <a:latin typeface="Calibri" charset="0"/>
@@ -5725,7 +4986,7 @@
                           <a:ea typeface="Calibri" pitchFamily="34" charset="-122"/>
                           <a:cs typeface="Calibri" pitchFamily="34" charset="-120"/>
                         </a:rPr>
-                        <a:t>—</a:t>
+                        <a:t>1,028</a:t>
                       </a:r>
                       <a:endParaRPr lang="en-US" sz="1100" dirty="0">
                         <a:latin typeface="Calibri" charset="0"/>
@@ -5793,7 +5054,281 @@
                           <a:ea typeface="Calibri" pitchFamily="34" charset="-122"/>
                           <a:cs typeface="Calibri" pitchFamily="34" charset="-120"/>
                         </a:rPr>
-                        <a:t>0.8755 sustained / 1.0 peak</a:t>
+                        <a:t>1,024</a:t>
+                      </a:r>
+                      <a:endParaRPr lang="en-US" sz="1100" dirty="0">
+                        <a:latin typeface="Calibri" charset="0"/>
+                        <a:ea typeface="Calibri" charset="0"/>
+                        <a:cs typeface="Calibri" charset="0"/>
+                      </a:endParaRPr>
+                    </a:p>
+                  </a:txBody>
+                  <a:tcPr marL="91440" marR="91440" marT="45720" marB="45720" anchor="ctr">
+                    <a:lnL w="7620" cap="flat" cmpd="sng" algn="ctr">
+                      <a:solidFill>
+                        <a:srgbClr val="DCE5EC"/>
+                      </a:solidFill>
+                      <a:prstDash val="solid"/>
+                      <a:round/>
+                      <a:headEnd type="none" w="med" len="med"/>
+                      <a:tailEnd type="none" w="med" len="med"/>
+                    </a:lnL>
+                    <a:lnR w="7620" cap="flat" cmpd="sng" algn="ctr">
+                      <a:solidFill>
+                        <a:srgbClr val="DCE5EC"/>
+                      </a:solidFill>
+                      <a:prstDash val="solid"/>
+                      <a:round/>
+                      <a:headEnd type="none" w="med" len="med"/>
+                      <a:tailEnd type="none" w="med" len="med"/>
+                    </a:lnR>
+                    <a:lnT w="7620" cap="flat" cmpd="sng" algn="ctr">
+                      <a:solidFill>
+                        <a:srgbClr val="DCE5EC"/>
+                      </a:solidFill>
+                      <a:prstDash val="solid"/>
+                      <a:round/>
+                      <a:headEnd type="none" w="med" len="med"/>
+                      <a:tailEnd type="none" w="med" len="med"/>
+                    </a:lnT>
+                    <a:lnB w="7620" cap="flat" cmpd="sng" algn="ctr">
+                      <a:solidFill>
+                        <a:srgbClr val="DCE5EC"/>
+                      </a:solidFill>
+                      <a:prstDash val="solid"/>
+                      <a:round/>
+                      <a:headEnd type="none" w="med" len="med"/>
+                      <a:tailEnd type="none" w="med" len="med"/>
+                    </a:lnB>
+                    <a:solidFill>
+                      <a:srgbClr val="FFFFFF"/>
+                    </a:solidFill>
+                  </a:tcPr>
+                </a:tc>
+                <a:tc>
+                  <a:txBody>
+                    <a:bodyPr/>
+                    <a:lstStyle/>
+                    <a:p>
+                      <a:pPr algn="l" indent="0" marL="0">
+                        <a:buNone/>
+                      </a:pPr>
+                      <a:r>
+                        <a:rPr lang="en-US" sz="1100" dirty="0">
+                          <a:solidFill>
+                            <a:srgbClr val="16222E"/>
+                          </a:solidFill>
+                          <a:latin typeface="Calibri" pitchFamily="34" charset="0"/>
+                          <a:ea typeface="Calibri" pitchFamily="34" charset="-122"/>
+                          <a:cs typeface="Calibri" pitchFamily="34" charset="-120"/>
+                        </a:rPr>
+                        <a:t>cycles</a:t>
+                      </a:r>
+                      <a:endParaRPr lang="en-US" sz="1100" dirty="0">
+                        <a:latin typeface="Calibri" charset="0"/>
+                        <a:ea typeface="Calibri" charset="0"/>
+                        <a:cs typeface="Calibri" charset="0"/>
+                      </a:endParaRPr>
+                    </a:p>
+                  </a:txBody>
+                  <a:tcPr marL="91440" marR="91440" marT="45720" marB="45720" anchor="ctr">
+                    <a:lnL w="7620" cap="flat" cmpd="sng" algn="ctr">
+                      <a:solidFill>
+                        <a:srgbClr val="DCE5EC"/>
+                      </a:solidFill>
+                      <a:prstDash val="solid"/>
+                      <a:round/>
+                      <a:headEnd type="none" w="med" len="med"/>
+                      <a:tailEnd type="none" w="med" len="med"/>
+                    </a:lnL>
+                    <a:lnR w="7620" cap="flat" cmpd="sng" algn="ctr">
+                      <a:solidFill>
+                        <a:srgbClr val="DCE5EC"/>
+                      </a:solidFill>
+                      <a:prstDash val="solid"/>
+                      <a:round/>
+                      <a:headEnd type="none" w="med" len="med"/>
+                      <a:tailEnd type="none" w="med" len="med"/>
+                    </a:lnR>
+                    <a:lnT w="7620" cap="flat" cmpd="sng" algn="ctr">
+                      <a:solidFill>
+                        <a:srgbClr val="DCE5EC"/>
+                      </a:solidFill>
+                      <a:prstDash val="solid"/>
+                      <a:round/>
+                      <a:headEnd type="none" w="med" len="med"/>
+                      <a:tailEnd type="none" w="med" len="med"/>
+                    </a:lnT>
+                    <a:lnB w="7620" cap="flat" cmpd="sng" algn="ctr">
+                      <a:solidFill>
+                        <a:srgbClr val="DCE5EC"/>
+                      </a:solidFill>
+                      <a:prstDash val="solid"/>
+                      <a:round/>
+                      <a:headEnd type="none" w="med" len="med"/>
+                      <a:tailEnd type="none" w="med" len="med"/>
+                    </a:lnB>
+                    <a:solidFill>
+                      <a:srgbClr val="FFFFFF"/>
+                    </a:solidFill>
+                  </a:tcPr>
+                </a:tc>
+              </a:tr>
+              <a:tr h="265176">
+                <a:tc>
+                  <a:txBody>
+                    <a:bodyPr/>
+                    <a:lstStyle/>
+                    <a:p>
+                      <a:pPr algn="l" indent="0" marL="0">
+                        <a:buNone/>
+                      </a:pPr>
+                      <a:r>
+                        <a:rPr lang="en-US" sz="1100" dirty="0">
+                          <a:solidFill>
+                            <a:srgbClr val="16222E"/>
+                          </a:solidFill>
+                          <a:latin typeface="Calibri" pitchFamily="34" charset="0"/>
+                          <a:ea typeface="Calibri" pitchFamily="34" charset="-122"/>
+                          <a:cs typeface="Calibri" pitchFamily="34" charset="-120"/>
+                        </a:rPr>
+                        <a:t>Throughput, sustained</a:t>
+                      </a:r>
+                      <a:endParaRPr lang="en-US" sz="1100" dirty="0">
+                        <a:latin typeface="Calibri" charset="0"/>
+                        <a:ea typeface="Calibri" charset="0"/>
+                        <a:cs typeface="Calibri" charset="0"/>
+                      </a:endParaRPr>
+                    </a:p>
+                  </a:txBody>
+                  <a:tcPr marL="91440" marR="91440" marT="45720" marB="45720" anchor="ctr">
+                    <a:lnL w="7620" cap="flat" cmpd="sng" algn="ctr">
+                      <a:solidFill>
+                        <a:srgbClr val="DCE5EC"/>
+                      </a:solidFill>
+                      <a:prstDash val="solid"/>
+                      <a:round/>
+                      <a:headEnd type="none" w="med" len="med"/>
+                      <a:tailEnd type="none" w="med" len="med"/>
+                    </a:lnL>
+                    <a:lnR w="7620" cap="flat" cmpd="sng" algn="ctr">
+                      <a:solidFill>
+                        <a:srgbClr val="DCE5EC"/>
+                      </a:solidFill>
+                      <a:prstDash val="solid"/>
+                      <a:round/>
+                      <a:headEnd type="none" w="med" len="med"/>
+                      <a:tailEnd type="none" w="med" len="med"/>
+                    </a:lnR>
+                    <a:lnT w="7620" cap="flat" cmpd="sng" algn="ctr">
+                      <a:solidFill>
+                        <a:srgbClr val="DCE5EC"/>
+                      </a:solidFill>
+                      <a:prstDash val="solid"/>
+                      <a:round/>
+                      <a:headEnd type="none" w="med" len="med"/>
+                      <a:tailEnd type="none" w="med" len="med"/>
+                    </a:lnT>
+                    <a:lnB w="7620" cap="flat" cmpd="sng" algn="ctr">
+                      <a:solidFill>
+                        <a:srgbClr val="DCE5EC"/>
+                      </a:solidFill>
+                      <a:prstDash val="solid"/>
+                      <a:round/>
+                      <a:headEnd type="none" w="med" len="med"/>
+                      <a:tailEnd type="none" w="med" len="med"/>
+                    </a:lnB>
+                    <a:solidFill>
+                      <a:srgbClr val="FFFFFF"/>
+                    </a:solidFill>
+                  </a:tcPr>
+                </a:tc>
+                <a:tc>
+                  <a:txBody>
+                    <a:bodyPr/>
+                    <a:lstStyle/>
+                    <a:p>
+                      <a:pPr algn="l" indent="0" marL="0">
+                        <a:buNone/>
+                      </a:pPr>
+                      <a:r>
+                        <a:rPr lang="en-US" sz="1100" dirty="0">
+                          <a:solidFill>
+                            <a:srgbClr val="16222E"/>
+                          </a:solidFill>
+                          <a:latin typeface="Calibri" pitchFamily="34" charset="0"/>
+                          <a:ea typeface="Calibri" pitchFamily="34" charset="-122"/>
+                          <a:cs typeface="Calibri" pitchFamily="34" charset="-120"/>
+                        </a:rPr>
+                        <a:t>0.8755</a:t>
+                      </a:r>
+                      <a:endParaRPr lang="en-US" sz="1100" dirty="0">
+                        <a:latin typeface="Calibri" charset="0"/>
+                        <a:ea typeface="Calibri" charset="0"/>
+                        <a:cs typeface="Calibri" charset="0"/>
+                      </a:endParaRPr>
+                    </a:p>
+                  </a:txBody>
+                  <a:tcPr marL="91440" marR="91440" marT="45720" marB="45720" anchor="ctr">
+                    <a:lnL w="7620" cap="flat" cmpd="sng" algn="ctr">
+                      <a:solidFill>
+                        <a:srgbClr val="DCE5EC"/>
+                      </a:solidFill>
+                      <a:prstDash val="solid"/>
+                      <a:round/>
+                      <a:headEnd type="none" w="med" len="med"/>
+                      <a:tailEnd type="none" w="med" len="med"/>
+                    </a:lnL>
+                    <a:lnR w="7620" cap="flat" cmpd="sng" algn="ctr">
+                      <a:solidFill>
+                        <a:srgbClr val="DCE5EC"/>
+                      </a:solidFill>
+                      <a:prstDash val="solid"/>
+                      <a:round/>
+                      <a:headEnd type="none" w="med" len="med"/>
+                      <a:tailEnd type="none" w="med" len="med"/>
+                    </a:lnR>
+                    <a:lnT w="7620" cap="flat" cmpd="sng" algn="ctr">
+                      <a:solidFill>
+                        <a:srgbClr val="DCE5EC"/>
+                      </a:solidFill>
+                      <a:prstDash val="solid"/>
+                      <a:round/>
+                      <a:headEnd type="none" w="med" len="med"/>
+                      <a:tailEnd type="none" w="med" len="med"/>
+                    </a:lnT>
+                    <a:lnB w="7620" cap="flat" cmpd="sng" algn="ctr">
+                      <a:solidFill>
+                        <a:srgbClr val="DCE5EC"/>
+                      </a:solidFill>
+                      <a:prstDash val="solid"/>
+                      <a:round/>
+                      <a:headEnd type="none" w="med" len="med"/>
+                      <a:tailEnd type="none" w="med" len="med"/>
+                    </a:lnB>
+                    <a:solidFill>
+                      <a:srgbClr val="FFFFFF"/>
+                    </a:solidFill>
+                  </a:tcPr>
+                </a:tc>
+                <a:tc>
+                  <a:txBody>
+                    <a:bodyPr/>
+                    <a:lstStyle/>
+                    <a:p>
+                      <a:pPr algn="l" indent="0" marL="0">
+                        <a:buNone/>
+                      </a:pPr>
+                      <a:r>
+                        <a:rPr lang="en-US" sz="1100" dirty="0">
+                          <a:solidFill>
+                            <a:srgbClr val="16222E"/>
+                          </a:solidFill>
+                          <a:latin typeface="Calibri" pitchFamily="34" charset="0"/>
+                          <a:ea typeface="Calibri" pitchFamily="34" charset="-122"/>
+                          <a:cs typeface="Calibri" pitchFamily="34" charset="-120"/>
+                        </a:rPr>
+                        <a:t>1.0000</a:t>
                       </a:r>
                       <a:endParaRPr lang="en-US" sz="1100" dirty="0">
                         <a:latin typeface="Calibri" charset="0"/>
@@ -5999,7 +5534,7 @@
                           <a:ea typeface="Calibri" pitchFamily="34" charset="-122"/>
                           <a:cs typeface="Calibri" pitchFamily="34" charset="-120"/>
                         </a:rPr>
-                        <a:t>—</a:t>
+                        <a:t>317 LUT, 275 FF</a:t>
                       </a:r>
                       <a:endParaRPr lang="en-US" sz="1100" dirty="0">
                         <a:latin typeface="Calibri" charset="0"/>
@@ -6067,7 +5602,281 @@
                           <a:ea typeface="Calibri" pitchFamily="34" charset="-122"/>
                           <a:cs typeface="Calibri" pitchFamily="34" charset="-120"/>
                         </a:rPr>
-                        <a:t>299 LUT, 274 FF, 9 DSP, 0 BRAM</a:t>
+                        <a:t>435 LUT, 325 FF</a:t>
+                      </a:r>
+                      <a:endParaRPr lang="en-US" sz="1100" dirty="0">
+                        <a:latin typeface="Calibri" charset="0"/>
+                        <a:ea typeface="Calibri" charset="0"/>
+                        <a:cs typeface="Calibri" charset="0"/>
+                      </a:endParaRPr>
+                    </a:p>
+                  </a:txBody>
+                  <a:tcPr marL="91440" marR="91440" marT="45720" marB="45720" anchor="ctr">
+                    <a:lnL w="7620" cap="flat" cmpd="sng" algn="ctr">
+                      <a:solidFill>
+                        <a:srgbClr val="DCE5EC"/>
+                      </a:solidFill>
+                      <a:prstDash val="solid"/>
+                      <a:round/>
+                      <a:headEnd type="none" w="med" len="med"/>
+                      <a:tailEnd type="none" w="med" len="med"/>
+                    </a:lnL>
+                    <a:lnR w="7620" cap="flat" cmpd="sng" algn="ctr">
+                      <a:solidFill>
+                        <a:srgbClr val="DCE5EC"/>
+                      </a:solidFill>
+                      <a:prstDash val="solid"/>
+                      <a:round/>
+                      <a:headEnd type="none" w="med" len="med"/>
+                      <a:tailEnd type="none" w="med" len="med"/>
+                    </a:lnR>
+                    <a:lnT w="7620" cap="flat" cmpd="sng" algn="ctr">
+                      <a:solidFill>
+                        <a:srgbClr val="DCE5EC"/>
+                      </a:solidFill>
+                      <a:prstDash val="solid"/>
+                      <a:round/>
+                      <a:headEnd type="none" w="med" len="med"/>
+                      <a:tailEnd type="none" w="med" len="med"/>
+                    </a:lnT>
+                    <a:lnB w="7620" cap="flat" cmpd="sng" algn="ctr">
+                      <a:solidFill>
+                        <a:srgbClr val="DCE5EC"/>
+                      </a:solidFill>
+                      <a:prstDash val="solid"/>
+                      <a:round/>
+                      <a:headEnd type="none" w="med" len="med"/>
+                      <a:tailEnd type="none" w="med" len="med"/>
+                    </a:lnB>
+                    <a:solidFill>
+                      <a:srgbClr val="FFFFFF"/>
+                    </a:solidFill>
+                  </a:tcPr>
+                </a:tc>
+                <a:tc>
+                  <a:txBody>
+                    <a:bodyPr/>
+                    <a:lstStyle/>
+                    <a:p>
+                      <a:pPr algn="l" indent="0" marL="0">
+                        <a:buNone/>
+                      </a:pPr>
+                      <a:r>
+                        <a:rPr lang="en-US" sz="1100" dirty="0">
+                          <a:solidFill>
+                            <a:srgbClr val="16222E"/>
+                          </a:solidFill>
+                          <a:latin typeface="Calibri" pitchFamily="34" charset="0"/>
+                          <a:ea typeface="Calibri" pitchFamily="34" charset="-122"/>
+                          <a:cs typeface="Calibri" pitchFamily="34" charset="-120"/>
+                        </a:rPr>
+                        <a:t>—</a:t>
+                      </a:r>
+                      <a:endParaRPr lang="en-US" sz="1100" dirty="0">
+                        <a:latin typeface="Calibri" charset="0"/>
+                        <a:ea typeface="Calibri" charset="0"/>
+                        <a:cs typeface="Calibri" charset="0"/>
+                      </a:endParaRPr>
+                    </a:p>
+                  </a:txBody>
+                  <a:tcPr marL="91440" marR="91440" marT="45720" marB="45720" anchor="ctr">
+                    <a:lnL w="7620" cap="flat" cmpd="sng" algn="ctr">
+                      <a:solidFill>
+                        <a:srgbClr val="DCE5EC"/>
+                      </a:solidFill>
+                      <a:prstDash val="solid"/>
+                      <a:round/>
+                      <a:headEnd type="none" w="med" len="med"/>
+                      <a:tailEnd type="none" w="med" len="med"/>
+                    </a:lnL>
+                    <a:lnR w="7620" cap="flat" cmpd="sng" algn="ctr">
+                      <a:solidFill>
+                        <a:srgbClr val="DCE5EC"/>
+                      </a:solidFill>
+                      <a:prstDash val="solid"/>
+                      <a:round/>
+                      <a:headEnd type="none" w="med" len="med"/>
+                      <a:tailEnd type="none" w="med" len="med"/>
+                    </a:lnR>
+                    <a:lnT w="7620" cap="flat" cmpd="sng" algn="ctr">
+                      <a:solidFill>
+                        <a:srgbClr val="DCE5EC"/>
+                      </a:solidFill>
+                      <a:prstDash val="solid"/>
+                      <a:round/>
+                      <a:headEnd type="none" w="med" len="med"/>
+                      <a:tailEnd type="none" w="med" len="med"/>
+                    </a:lnT>
+                    <a:lnB w="7620" cap="flat" cmpd="sng" algn="ctr">
+                      <a:solidFill>
+                        <a:srgbClr val="DCE5EC"/>
+                      </a:solidFill>
+                      <a:prstDash val="solid"/>
+                      <a:round/>
+                      <a:headEnd type="none" w="med" len="med"/>
+                      <a:tailEnd type="none" w="med" len="med"/>
+                    </a:lnB>
+                    <a:solidFill>
+                      <a:srgbClr val="FFFFFF"/>
+                    </a:solidFill>
+                  </a:tcPr>
+                </a:tc>
+              </a:tr>
+              <a:tr h="265176">
+                <a:tc>
+                  <a:txBody>
+                    <a:bodyPr/>
+                    <a:lstStyle/>
+                    <a:p>
+                      <a:pPr algn="l" indent="0" marL="0">
+                        <a:buNone/>
+                      </a:pPr>
+                      <a:r>
+                        <a:rPr lang="en-US" sz="1100" dirty="0">
+                          <a:solidFill>
+                            <a:srgbClr val="16222E"/>
+                          </a:solidFill>
+                          <a:latin typeface="Calibri" pitchFamily="34" charset="0"/>
+                          <a:ea typeface="Calibri" pitchFamily="34" charset="-122"/>
+                          <a:cs typeface="Calibri" pitchFamily="34" charset="-120"/>
+                        </a:rPr>
+                        <a:t>Block RAM</a:t>
+                      </a:r>
+                      <a:endParaRPr lang="en-US" sz="1100" dirty="0">
+                        <a:latin typeface="Calibri" charset="0"/>
+                        <a:ea typeface="Calibri" charset="0"/>
+                        <a:cs typeface="Calibri" charset="0"/>
+                      </a:endParaRPr>
+                    </a:p>
+                  </a:txBody>
+                  <a:tcPr marL="91440" marR="91440" marT="45720" marB="45720" anchor="ctr">
+                    <a:lnL w="7620" cap="flat" cmpd="sng" algn="ctr">
+                      <a:solidFill>
+                        <a:srgbClr val="DCE5EC"/>
+                      </a:solidFill>
+                      <a:prstDash val="solid"/>
+                      <a:round/>
+                      <a:headEnd type="none" w="med" len="med"/>
+                      <a:tailEnd type="none" w="med" len="med"/>
+                    </a:lnL>
+                    <a:lnR w="7620" cap="flat" cmpd="sng" algn="ctr">
+                      <a:solidFill>
+                        <a:srgbClr val="DCE5EC"/>
+                      </a:solidFill>
+                      <a:prstDash val="solid"/>
+                      <a:round/>
+                      <a:headEnd type="none" w="med" len="med"/>
+                      <a:tailEnd type="none" w="med" len="med"/>
+                    </a:lnR>
+                    <a:lnT w="7620" cap="flat" cmpd="sng" algn="ctr">
+                      <a:solidFill>
+                        <a:srgbClr val="DCE5EC"/>
+                      </a:solidFill>
+                      <a:prstDash val="solid"/>
+                      <a:round/>
+                      <a:headEnd type="none" w="med" len="med"/>
+                      <a:tailEnd type="none" w="med" len="med"/>
+                    </a:lnT>
+                    <a:lnB w="7620" cap="flat" cmpd="sng" algn="ctr">
+                      <a:solidFill>
+                        <a:srgbClr val="DCE5EC"/>
+                      </a:solidFill>
+                      <a:prstDash val="solid"/>
+                      <a:round/>
+                      <a:headEnd type="none" w="med" len="med"/>
+                      <a:tailEnd type="none" w="med" len="med"/>
+                    </a:lnB>
+                    <a:solidFill>
+                      <a:srgbClr val="FFFFFF"/>
+                    </a:solidFill>
+                  </a:tcPr>
+                </a:tc>
+                <a:tc>
+                  <a:txBody>
+                    <a:bodyPr/>
+                    <a:lstStyle/>
+                    <a:p>
+                      <a:pPr algn="l" indent="0" marL="0">
+                        <a:buNone/>
+                      </a:pPr>
+                      <a:r>
+                        <a:rPr lang="en-US" sz="1100" dirty="0">
+                          <a:solidFill>
+                            <a:srgbClr val="16222E"/>
+                          </a:solidFill>
+                          <a:latin typeface="Calibri" pitchFamily="34" charset="0"/>
+                          <a:ea typeface="Calibri" pitchFamily="34" charset="-122"/>
+                          <a:cs typeface="Calibri" pitchFamily="34" charset="-120"/>
+                        </a:rPr>
+                        <a:t>0</a:t>
+                      </a:r>
+                      <a:endParaRPr lang="en-US" sz="1100" dirty="0">
+                        <a:latin typeface="Calibri" charset="0"/>
+                        <a:ea typeface="Calibri" charset="0"/>
+                        <a:cs typeface="Calibri" charset="0"/>
+                      </a:endParaRPr>
+                    </a:p>
+                  </a:txBody>
+                  <a:tcPr marL="91440" marR="91440" marT="45720" marB="45720" anchor="ctr">
+                    <a:lnL w="7620" cap="flat" cmpd="sng" algn="ctr">
+                      <a:solidFill>
+                        <a:srgbClr val="DCE5EC"/>
+                      </a:solidFill>
+                      <a:prstDash val="solid"/>
+                      <a:round/>
+                      <a:headEnd type="none" w="med" len="med"/>
+                      <a:tailEnd type="none" w="med" len="med"/>
+                    </a:lnL>
+                    <a:lnR w="7620" cap="flat" cmpd="sng" algn="ctr">
+                      <a:solidFill>
+                        <a:srgbClr val="DCE5EC"/>
+                      </a:solidFill>
+                      <a:prstDash val="solid"/>
+                      <a:round/>
+                      <a:headEnd type="none" w="med" len="med"/>
+                      <a:tailEnd type="none" w="med" len="med"/>
+                    </a:lnR>
+                    <a:lnT w="7620" cap="flat" cmpd="sng" algn="ctr">
+                      <a:solidFill>
+                        <a:srgbClr val="DCE5EC"/>
+                      </a:solidFill>
+                      <a:prstDash val="solid"/>
+                      <a:round/>
+                      <a:headEnd type="none" w="med" len="med"/>
+                      <a:tailEnd type="none" w="med" len="med"/>
+                    </a:lnT>
+                    <a:lnB w="7620" cap="flat" cmpd="sng" algn="ctr">
+                      <a:solidFill>
+                        <a:srgbClr val="DCE5EC"/>
+                      </a:solidFill>
+                      <a:prstDash val="solid"/>
+                      <a:round/>
+                      <a:headEnd type="none" w="med" len="med"/>
+                      <a:tailEnd type="none" w="med" len="med"/>
+                    </a:lnB>
+                    <a:solidFill>
+                      <a:srgbClr val="FFFFFF"/>
+                    </a:solidFill>
+                  </a:tcPr>
+                </a:tc>
+                <a:tc>
+                  <a:txBody>
+                    <a:bodyPr/>
+                    <a:lstStyle/>
+                    <a:p>
+                      <a:pPr algn="l" indent="0" marL="0">
+                        <a:buNone/>
+                      </a:pPr>
+                      <a:r>
+                        <a:rPr lang="en-US" sz="1100" dirty="0">
+                          <a:solidFill>
+                            <a:srgbClr val="16222E"/>
+                          </a:solidFill>
+                          <a:latin typeface="Calibri" pitchFamily="34" charset="0"/>
+                          <a:ea typeface="Calibri" pitchFamily="34" charset="-122"/>
+                          <a:cs typeface="Calibri" pitchFamily="34" charset="-120"/>
+                        </a:rPr>
+                        <a:t>0</a:t>
                       </a:r>
                       <a:endParaRPr lang="en-US" sz="1100" dirty="0">
                         <a:latin typeface="Calibri" charset="0"/>
@@ -6273,7 +6082,7 @@
                           <a:ea typeface="Calibri" pitchFamily="34" charset="-122"/>
                           <a:cs typeface="Calibri" pitchFamily="34" charset="-120"/>
                         </a:rPr>
-                        <a:t>—</a:t>
+                        <a:t>167.0</a:t>
                       </a:r>
                       <a:endParaRPr lang="en-US" sz="1100" dirty="0">
                         <a:latin typeface="Calibri" charset="0"/>
@@ -6341,7 +6150,7 @@
                           <a:ea typeface="Calibri" pitchFamily="34" charset="-122"/>
                           <a:cs typeface="Calibri" pitchFamily="34" charset="-120"/>
                         </a:rPr>
-                        <a:t>174.4</a:t>
+                        <a:t>165.7</a:t>
                       </a:r>
                       <a:endParaRPr lang="en-US" sz="1100" dirty="0">
                         <a:latin typeface="Calibri" charset="0"/>
@@ -6547,7 +6356,7 @@
                           <a:ea typeface="Calibri" pitchFamily="34" charset="-122"/>
                           <a:cs typeface="Calibri" pitchFamily="34" charset="-120"/>
                         </a:rPr>
-                        <a:t>—</a:t>
+                        <a:t>All met, score 0</a:t>
                       </a:r>
                       <a:endParaRPr lang="en-US" sz="1100" dirty="0">
                         <a:latin typeface="Calibri" charset="0"/>
@@ -6615,7 +6424,7 @@
                           <a:ea typeface="Calibri" pitchFamily="34" charset="-122"/>
                           <a:cs typeface="Calibri" pitchFamily="34" charset="-120"/>
                         </a:rPr>
-                        <a:t>All constraints met, score 0</a:t>
+                        <a:t>All met, score 0</a:t>
                       </a:r>
                       <a:endParaRPr lang="en-US" sz="1100" dirty="0">
                         <a:latin typeface="Calibri" charset="0"/>
@@ -6821,7 +6630,7 @@
                           <a:ea typeface="Calibri" pitchFamily="34" charset="-122"/>
                           <a:cs typeface="Calibri" pitchFamily="34" charset="-120"/>
                         </a:rPr>
-                        <a:t>—</a:t>
+                        <a:t>476 (21 dyn / 455 static)</a:t>
                       </a:r>
                       <a:endParaRPr lang="en-US" sz="1100" dirty="0">
                         <a:latin typeface="Calibri" charset="0"/>
@@ -7027,7 +6836,7 @@
                           <a:ea typeface="Calibri" pitchFamily="34" charset="-122"/>
                           <a:cs typeface="Calibri" pitchFamily="34" charset="-120"/>
                         </a:rPr>
-                        <a:t>Verification status</a:t>
+                        <a:t>Verification</a:t>
                       </a:r>
                       <a:endParaRPr lang="en-US" sz="1100" dirty="0">
                         <a:latin typeface="Calibri" charset="0"/>
@@ -7095,7 +6904,7 @@
                           <a:ea typeface="Calibri" pitchFamily="34" charset="-122"/>
                           <a:cs typeface="Calibri" pitchFamily="34" charset="-120"/>
                         </a:rPr>
-                        <a:t>—</a:t>
+                        <a:t>78/78 bit-exact</a:t>
                       </a:r>
                       <a:endParaRPr lang="en-US" sz="1100" dirty="0">
                         <a:latin typeface="Calibri" charset="0"/>
@@ -7163,7 +6972,7 @@
                           <a:ea typeface="Calibri" pitchFamily="34" charset="-122"/>
                           <a:cs typeface="Calibri" pitchFamily="34" charset="-120"/>
                         </a:rPr>
-                        <a:t>78 / 78 cases bit-exact</a:t>
+                        <a:t>1024/1024, 0-cycle max gap</a:t>
                       </a:r>
                       <a:endParaRPr lang="en-US" sz="1100" dirty="0">
                         <a:latin typeface="Calibri" charset="0"/>
@@ -7369,7 +7178,7 @@
                           <a:ea typeface="Calibri" pitchFamily="34" charset="-122"/>
                           <a:cs typeface="Calibri" pitchFamily="34" charset="-120"/>
                         </a:rPr>
-                        <a:t>—</a:t>
+                        <a:t>2.398 × 10⁻³</a:t>
                       </a:r>
                       <a:endParaRPr lang="en-US" sz="1100" dirty="0">
                         <a:latin typeface="Calibri" charset="0"/>
@@ -7437,7 +7246,7 @@
                           <a:ea typeface="Calibri" pitchFamily="34" charset="-122"/>
                           <a:cs typeface="Calibri" pitchFamily="34" charset="-120"/>
                         </a:rPr>
-                        <a:t>2.456 × 10⁻³</a:t>
+                        <a:t>2.374 × 10⁻³</a:t>
                       </a:r>
                       <a:endParaRPr lang="en-US" sz="1100" dirty="0">
                         <a:latin typeface="Calibri" charset="0"/>
@@ -7569,9 +7378,9 @@
 </p:sld>
 </file>
 
-<file path=ppt/slides/slide12.xml><?xml version="1.0" encoding="utf-8"?>
+<file path=ppt/slides/slide13.xml><?xml version="1.0" encoding="utf-8"?>
 <p:sld xmlns:a="http://schemas.openxmlformats.org/drawingml/2006/main" xmlns:r="http://schemas.openxmlformats.org/officeDocument/2006/relationships" xmlns:p="http://schemas.openxmlformats.org/presentationml/2006/main">
-  <p:cSld name="Slide 12">
+  <p:cSld name="Slide 13">
     <p:bg>
       <p:bgPr>
         <a:solidFill>
@@ -7785,7 +7594,7 @@
                 <a:ea typeface="Calibri" pitchFamily="34" charset="-122"/>
                 <a:cs typeface="Calibri" pitchFamily="34" charset="-120"/>
               </a:rPr>
-              <a:t>One output pixel per cycle, zero BRAM, 299 LUTs, 74% frequency headroom.</a:t>
+              <a:t>One output pixel per cycle, zero BRAM, 317 LUTs, 67% frequency headroom.</a:t>
             </a:r>
             <a:endParaRPr lang="en-US" sz="1300" dirty="0"/>
           </a:p>
@@ -8411,7 +8220,7 @@
                 <a:ea typeface="Cambria" pitchFamily="34" charset="-122"/>
                 <a:cs typeface="Cambria" pitchFamily="34" charset="-120"/>
               </a:rPr>
-              <a:t>299</a:t>
+              <a:t>317</a:t>
             </a:r>
             <a:endParaRPr lang="en-US" sz="4000" dirty="0"/>
           </a:p>
@@ -8621,7 +8430,7 @@
                 <a:ea typeface="Cambria" pitchFamily="34" charset="-122"/>
                 <a:cs typeface="Cambria" pitchFamily="34" charset="-120"/>
               </a:rPr>
-              <a:t>174.4</a:t>
+              <a:t>167.0</a:t>
             </a:r>
             <a:endParaRPr lang="en-US" sz="4000" dirty="0"/>
           </a:p>
@@ -9146,7 +8955,7 @@
                 <a:ea typeface="Cambria" pitchFamily="34" charset="-122"/>
                 <a:cs typeface="Cambria" pitchFamily="34" charset="-120"/>
               </a:rPr>
-              <a:t>2.456×10⁻³</a:t>
+              <a:t>2.398×10⁻³</a:t>
             </a:r>
             <a:endParaRPr lang="en-US" sz="3000" dirty="0"/>
           </a:p>
@@ -14762,7 +14571,7 @@
                           <a:ea typeface="Calibri" pitchFamily="34" charset="-122"/>
                           <a:cs typeface="Calibri" pitchFamily="34" charset="-120"/>
                         </a:rPr>
-                        <a:t>299</a:t>
+                        <a:t>317</a:t>
                       </a:r>
                       <a:endParaRPr lang="en-US" sz="1250" dirty="0">
                         <a:latin typeface="Calibri" charset="0"/>
@@ -15380,7 +15189,7 @@
                           <a:ea typeface="Calibri" pitchFamily="34" charset="-122"/>
                           <a:cs typeface="Calibri" pitchFamily="34" charset="-120"/>
                         </a:rPr>
-                        <a:t>749</a:t>
+                        <a:t>767</a:t>
                       </a:r>
                       <a:endParaRPr lang="en-US" sz="1250" dirty="0">
                         <a:latin typeface="Calibri" charset="0"/>
@@ -15586,7 +15395,7 @@
                           <a:ea typeface="Calibri" pitchFamily="34" charset="-122"/>
                           <a:cs typeface="Calibri" pitchFamily="34" charset="-120"/>
                         </a:rPr>
-                        <a:t>174.4 MHz</a:t>
+                        <a:t>167.0 MHz</a:t>
                       </a:r>
                       <a:endParaRPr lang="en-US" sz="1250" dirty="0">
                         <a:latin typeface="Calibri" charset="0"/>
@@ -15792,7 +15601,7 @@
                           <a:ea typeface="Calibri" pitchFamily="34" charset="-122"/>
                           <a:cs typeface="Calibri" pitchFamily="34" charset="-120"/>
                         </a:rPr>
-                        <a:t>2.456×10⁻³</a:t>
+                        <a:t>2.398×10⁻³</a:t>
                       </a:r>
                       <a:endParaRPr lang="en-US" sz="1250" dirty="0">
                         <a:latin typeface="Calibri" charset="0"/>
@@ -16047,7 +15856,7 @@
                 <a:ea typeface="Calibri" pitchFamily="34" charset="-122"/>
                 <a:cs typeface="Calibri" pitchFamily="34" charset="-120"/>
               </a:rPr>
-              <a:t>Removing the DSPs saved 450 penalty units but added 1,013 LUTs — a net 563 units worse, plus a 24% loss of maximum frequency.</a:t>
+              <a:t>Removing the DSPs saved 450 penalty units but added 1,001 LUTs — a net 551 units worse, plus a 24% loss of maximum frequency.</a:t>
             </a:r>
             <a:endParaRPr lang="en-US" sz="1200" dirty="0"/>
           </a:p>
@@ -16076,7 +15885,7 @@
                 <a:ea typeface="Calibri" pitchFamily="34" charset="-122"/>
                 <a:cs typeface="Calibri" pitchFamily="34" charset="-120"/>
               </a:rPr>
-              <a:t>Build A ships, with a 76% higher Figure of Merit. Reasoning from the formula alone would have selected the worse design.</a:t>
+              <a:t>Build A ships, with a 72% higher Figure of Merit. Reasoning from the formula alone would have selected the worse design.</a:t>
             </a:r>
             <a:endParaRPr lang="en-US" sz="1200" dirty="0"/>
           </a:p>

</xml_diff>

<commit_message>
Sync presentation with measured SAIF power figures (472.27mW, FoM 2.417e-3/2.393e-3)
</commit_message>
<xml_diff>
--- a/docs/SSCS2026_presentation.pptx
+++ b/docs/SSCS2026_presentation.pptx
@@ -256,10 +256,10 @@
               <c:strCache>
                 <c:ptCount val="2"/>
                 <c:pt idx="0">
-                  <c:v>Static leakage (455 mW)</c:v>
+                  <c:v>Static leakage (454.77 mW)</c:v>
                 </c:pt>
                 <c:pt idx="1">
-                  <c:v>Dynamic (21 mW)</c:v>
+                  <c:v>Dynamic (17.50 mW)</c:v>
                 </c:pt>
               </c:strCache>
             </c:strRef>
@@ -270,10 +270,10 @@
               <c:numCache>
                 <c:ptCount val="2"/>
                 <c:pt idx="0">
-                  <c:v>455</c:v>
+                  <c:v>454.77</c:v>
                 </c:pt>
                 <c:pt idx="1">
-                  <c:v>21</c:v>
+                  <c:v>17.50</c:v>
                 </c:pt>
               </c:numCache>
             </c:numRef>
@@ -3347,7 +3347,7 @@
                 <a:ea typeface="Calibri" pitchFamily="34" charset="-122"/>
                 <a:cs typeface="Calibri" pitchFamily="34" charset="-120"/>
               </a:rPr>
-              <a:t>Only 21 mW of the 476 mW total is dynamic. The remaining 455 mW is static leakage inherent to the 65 nm Virtex-5 process and independent of the design — it is the same figure our earlier work measured on this board.</a:t>
+              <a:t>Only 17.50 mW of the 472.27 mW total is dynamic, measured via post-route SAIF activity capture at 100% net matching. The remaining 454.77 mW is static leakage inherent to the 65 nm Virtex-5 process and independent of the design.</a:t>
             </a:r>
             <a:endParaRPr lang="en-US" sz="1300" dirty="0"/>
           </a:p>
@@ -6630,7 +6630,7 @@
                           <a:ea typeface="Calibri" pitchFamily="34" charset="-122"/>
                           <a:cs typeface="Calibri" pitchFamily="34" charset="-120"/>
                         </a:rPr>
-                        <a:t>476 (21 dyn / 455 static)</a:t>
+                        <a:t>472.27 (17.50 dyn / 454.77 static)</a:t>
                       </a:r>
                       <a:endParaRPr lang="en-US" sz="1100" dirty="0">
                         <a:latin typeface="Calibri" charset="0"/>
@@ -6698,7 +6698,7 @@
                           <a:ea typeface="Calibri" pitchFamily="34" charset="-122"/>
                           <a:cs typeface="Calibri" pitchFamily="34" charset="-120"/>
                         </a:rPr>
-                        <a:t>476 (21 dyn / 455 static)</a:t>
+                        <a:t>472.27 (17.50 dyn / 454.77 static)</a:t>
                       </a:r>
                       <a:endParaRPr lang="en-US" sz="1100" dirty="0">
                         <a:latin typeface="Calibri" charset="0"/>
@@ -7178,7 +7178,7 @@
                           <a:ea typeface="Calibri" pitchFamily="34" charset="-122"/>
                           <a:cs typeface="Calibri" pitchFamily="34" charset="-120"/>
                         </a:rPr>
-                        <a:t>2.398 × 10⁻³</a:t>
+                        <a:t>2.417 × 10⁻³</a:t>
                       </a:r>
                       <a:endParaRPr lang="en-US" sz="1100" dirty="0">
                         <a:latin typeface="Calibri" charset="0"/>
@@ -7246,7 +7246,7 @@
                           <a:ea typeface="Calibri" pitchFamily="34" charset="-122"/>
                           <a:cs typeface="Calibri" pitchFamily="34" charset="-120"/>
                         </a:rPr>
-                        <a:t>2.374 × 10⁻³</a:t>
+                        <a:t>2.393 × 10⁻³</a:t>
                       </a:r>
                       <a:endParaRPr lang="en-US" sz="1100" dirty="0">
                         <a:latin typeface="Calibri" charset="0"/>
@@ -8535,7 +8535,7 @@
                 <a:ea typeface="Cambria" pitchFamily="34" charset="-122"/>
                 <a:cs typeface="Cambria" pitchFamily="34" charset="-120"/>
               </a:rPr>
-              <a:t>476</a:t>
+              <a:t>472.27</a:t>
             </a:r>
             <a:endParaRPr lang="en-US" sz="4000" dirty="0"/>
           </a:p>
@@ -8955,7 +8955,7 @@
                 <a:ea typeface="Cambria" pitchFamily="34" charset="-122"/>
                 <a:cs typeface="Cambria" pitchFamily="34" charset="-120"/>
               </a:rPr>
-              <a:t>2.398×10⁻³</a:t>
+              <a:t>2.417×10⁻³</a:t>
             </a:r>
             <a:endParaRPr lang="en-US" sz="3000" dirty="0"/>
           </a:p>
@@ -15601,7 +15601,7 @@
                           <a:ea typeface="Calibri" pitchFamily="34" charset="-122"/>
                           <a:cs typeface="Calibri" pitchFamily="34" charset="-120"/>
                         </a:rPr>
-                        <a:t>2.398×10⁻³</a:t>
+                        <a:t>2.417×10⁻³</a:t>
                       </a:r>
                       <a:endParaRPr lang="en-US" sz="1250" dirty="0">
                         <a:latin typeface="Calibri" charset="0"/>

</xml_diff>